<commit_message>
Update TCO calculations for 7,000 desktops
Scale all cost estimates from 100 to 7,000 users with appropriate
economy-of-scale factors:
- Hardware: volume discounts on server/storage procurement
- Licenses: EA volume licensing, bulk subscription discounts
- Support: sub-linear scaling (Microsoft Unified, etc.)
- Personnel: 6-10 FTE instead of linear scaling
- Implementation: sub-linear (complexity grows, not 70x)

Adjusted scoring matrix for enterprise scale:
- RDS Funktionsumfang 5→4 (sitzungsbasiert limits at 7k users)
- RDS Betriebsaufwand 8→6 (~100 RDS hosts to manage)
- AVD Kosten 4→5 (multi-session + reserved instances at scale)
- OpenDesktop Betriebsaufwand 3→2 (~10 FTE needed)

TCO range: 9,8 Mio. € (RDS) to 34,0 Mio. € (Omnissa Horizon)

https://claude.ai/code/session_015mHD4NfjMbda5YrGvujwfD
</commit_message>
<xml_diff>
--- a/docs/VDI-Vergleichsanalyse.pptx
+++ b/docs/VDI-Vergleichsanalyse.pptx
@@ -14470,7 +14470,7 @@
                 </a:solidFill>
                 <a:latin typeface="AOK Bundesweit"/>
               </a:rPr>
-              <a:t>TCO 5J / 100 User: ~370.000 € (~740 €/User/Jahr)</a:t>
+              <a:t>TCO 5J / 7.000 User: ~16,5 Mio. € (~471 €/User/Jahr)</a:t>
             </a:r>
           </a:p>
         </p:txBody>
@@ -14802,7 +14802,7 @@
                 </a:solidFill>
                 <a:latin typeface="AOK Bundesweit"/>
               </a:rPr>
-              <a:t>TCO 5J / 100 User: ~325.000 € (~650 €/User/Jahr)</a:t>
+              <a:t>TCO 5J / 7.000 User: ~15,5 Mio. € (~443 €/User/Jahr)</a:t>
             </a:r>
           </a:p>
         </p:txBody>
@@ -16900,7 +16900,7 @@
           <a:lstStyle/>
           <a:p>
             <a:r>
-              <a:t>TCO-Kostenvergleich — 5 Jahre, 100 Benutzer</a:t>
+              <a:t>TCO-Kostenvergleich — 5 Jahre, 7.000 Benutzer</a:t>
             </a:r>
           </a:p>
         </p:txBody>
@@ -16921,7 +16921,7 @@
           <a:lstStyle/>
           <a:p>
             <a:r>
-              <a:t>Total Cost of Ownership inkl. Hardware, Lizenzen, Support, Personal</a:t>
+              <a:t>Total Cost of Ownership inkl. Hardware, Lizenzen, Support, Personal (in Mio. €)</a:t>
             </a:r>
           </a:p>
         </p:txBody>
@@ -17135,7 +17135,8 @@
                           </a:solidFill>
                           <a:latin typeface="AOK Bundesweit"/>
                         </a:rPr>
-                        <a:t>Hardware (einmalig)</a:t>
+                        <a:t>Hardware (Server,
+Storage, Netzwerk)</a:t>
                       </a:r>
                     </a:p>
                   </a:txBody>
@@ -17158,7 +17159,7 @@
                           </a:solidFill>
                           <a:latin typeface="AOK Bundesweit"/>
                         </a:rPr>
-                        <a:t>30.000 €</a:t>
+                        <a:t>2,0 Mio.</a:t>
                       </a:r>
                     </a:p>
                   </a:txBody>
@@ -17181,7 +17182,7 @@
                           </a:solidFill>
                           <a:latin typeface="AOK Bundesweit"/>
                         </a:rPr>
-                        <a:t>70.000 €</a:t>
+                        <a:t>5,0 Mio.</a:t>
                       </a:r>
                     </a:p>
                   </a:txBody>
@@ -17227,7 +17228,7 @@
                           </a:solidFill>
                           <a:latin typeface="AOK Bundesweit"/>
                         </a:rPr>
-                        <a:t>60.000 €</a:t>
+                        <a:t>4,5 Mio.</a:t>
                       </a:r>
                     </a:p>
                   </a:txBody>
@@ -17250,7 +17251,7 @@
                           </a:solidFill>
                           <a:latin typeface="AOK Bundesweit"/>
                         </a:rPr>
-                        <a:t>45.000 €</a:t>
+                        <a:t>3,5 Mio.</a:t>
                       </a:r>
                     </a:p>
                   </a:txBody>
@@ -17273,7 +17274,7 @@
                           </a:solidFill>
                           <a:latin typeface="AOK Bundesweit"/>
                         </a:rPr>
-                        <a:t>45.000 €</a:t>
+                        <a:t>3,5 Mio.</a:t>
                       </a:r>
                     </a:p>
                   </a:txBody>
@@ -17317,7 +17318,7 @@
                           </a:solidFill>
                           <a:latin typeface="AOK Bundesweit"/>
                         </a:rPr>
-                        <a:t>60.000 €</a:t>
+                        <a:t>3,5 Mio.</a:t>
                       </a:r>
                     </a:p>
                   </a:txBody>
@@ -17336,7 +17337,7 @@
                           </a:solidFill>
                           <a:latin typeface="AOK Bundesweit"/>
                         </a:rPr>
-                        <a:t>350.000 €</a:t>
+                        <a:t>16,0 Mio.</a:t>
                       </a:r>
                     </a:p>
                   </a:txBody>
@@ -17355,7 +17356,7 @@
                           </a:solidFill>
                           <a:latin typeface="AOK Bundesweit"/>
                         </a:rPr>
-                        <a:t>500.000 €</a:t>
+                        <a:t>18,0 Mio.</a:t>
                       </a:r>
                     </a:p>
                   </a:txBody>
@@ -17374,7 +17375,7 @@
                           </a:solidFill>
                           <a:latin typeface="AOK Bundesweit"/>
                         </a:rPr>
-                        <a:t>350.000 €</a:t>
+                        <a:t>18,0 Mio.</a:t>
                       </a:r>
                     </a:p>
                   </a:txBody>
@@ -17412,7 +17413,7 @@
                           </a:solidFill>
                           <a:latin typeface="AOK Bundesweit"/>
                         </a:rPr>
-                        <a:t>50.000 €</a:t>
+                        <a:t>2,5 Mio.</a:t>
                       </a:r>
                     </a:p>
                   </a:txBody>
@@ -17456,7 +17457,7 @@
                           </a:solidFill>
                           <a:latin typeface="AOK Bundesweit"/>
                         </a:rPr>
-                        <a:t>20.000 €</a:t>
+                        <a:t>inkl. EA</a:t>
                       </a:r>
                     </a:p>
                   </a:txBody>
@@ -17525,7 +17526,7 @@
                           </a:solidFill>
                           <a:latin typeface="AOK Bundesweit"/>
                         </a:rPr>
-                        <a:t>60.000 €</a:t>
+                        <a:t>3,5 Mio.</a:t>
                       </a:r>
                     </a:p>
                   </a:txBody>
@@ -17548,7 +17549,7 @@
                           </a:solidFill>
                           <a:latin typeface="AOK Bundesweit"/>
                         </a:rPr>
-                        <a:t>60.000 €</a:t>
+                        <a:t>3,5 Mio.</a:t>
                       </a:r>
                     </a:p>
                   </a:txBody>
@@ -17571,7 +17572,7 @@
                           </a:solidFill>
                           <a:latin typeface="AOK Bundesweit"/>
                         </a:rPr>
-                        <a:t>60.000 €</a:t>
+                        <a:t>3,5 Mio.</a:t>
                       </a:r>
                     </a:p>
                   </a:txBody>
@@ -17615,7 +17616,7 @@
                           </a:solidFill>
                           <a:latin typeface="AOK Bundesweit"/>
                         </a:rPr>
-                        <a:t>30.000 €</a:t>
+                        <a:t>0,8 Mio.</a:t>
                       </a:r>
                     </a:p>
                   </a:txBody>
@@ -17634,7 +17635,7 @@
                           </a:solidFill>
                           <a:latin typeface="AOK Bundesweit"/>
                         </a:rPr>
-                        <a:t>50.000 €</a:t>
+                        <a:t>2,0 Mio.</a:t>
                       </a:r>
                     </a:p>
                   </a:txBody>
@@ -17653,7 +17654,7 @@
                           </a:solidFill>
                           <a:latin typeface="AOK Bundesweit"/>
                         </a:rPr>
-                        <a:t>25.000 €</a:t>
+                        <a:t>1,0 Mio.</a:t>
                       </a:r>
                     </a:p>
                   </a:txBody>
@@ -17672,7 +17673,7 @@
                           </a:solidFill>
                           <a:latin typeface="AOK Bundesweit"/>
                         </a:rPr>
-                        <a:t>50.000 €</a:t>
+                        <a:t>2,5 Mio.</a:t>
                       </a:r>
                     </a:p>
                   </a:txBody>
@@ -17691,7 +17692,7 @@
                           </a:solidFill>
                           <a:latin typeface="AOK Bundesweit"/>
                         </a:rPr>
-                        <a:t>50.000 €</a:t>
+                        <a:t>2,5 Mio.</a:t>
                       </a:r>
                     </a:p>
                   </a:txBody>
@@ -17710,7 +17711,7 @@
                           </a:solidFill>
                           <a:latin typeface="AOK Bundesweit"/>
                         </a:rPr>
-                        <a:t>25.000 €</a:t>
+                        <a:t>1,5 Mio.</a:t>
                       </a:r>
                     </a:p>
                   </a:txBody>
@@ -17754,7 +17755,7 @@
                           </a:solidFill>
                           <a:latin typeface="AOK Bundesweit"/>
                         </a:rPr>
-                        <a:t>15.000 €</a:t>
+                        <a:t>0,5 Mio.</a:t>
                       </a:r>
                     </a:p>
                   </a:txBody>
@@ -17777,7 +17778,7 @@
                           </a:solidFill>
                           <a:latin typeface="AOK Bundesweit"/>
                         </a:rPr>
-                        <a:t>30.000 €</a:t>
+                        <a:t>1,5 Mio.</a:t>
                       </a:r>
                     </a:p>
                   </a:txBody>
@@ -17800,7 +17801,7 @@
                           </a:solidFill>
                           <a:latin typeface="AOK Bundesweit"/>
                         </a:rPr>
-                        <a:t>20.000 €</a:t>
+                        <a:t>0,8 Mio.</a:t>
                       </a:r>
                     </a:p>
                   </a:txBody>
@@ -17823,7 +17824,7 @@
                           </a:solidFill>
                           <a:latin typeface="AOK Bundesweit"/>
                         </a:rPr>
-                        <a:t>30.000 €</a:t>
+                        <a:t>1,5 Mio.</a:t>
                       </a:r>
                     </a:p>
                   </a:txBody>
@@ -17846,7 +17847,7 @@
                           </a:solidFill>
                           <a:latin typeface="AOK Bundesweit"/>
                         </a:rPr>
-                        <a:t>40.000 €</a:t>
+                        <a:t>2,0 Mio.</a:t>
                       </a:r>
                     </a:p>
                   </a:txBody>
@@ -17869,7 +17870,7 @@
                           </a:solidFill>
                           <a:latin typeface="AOK Bundesweit"/>
                         </a:rPr>
-                        <a:t>20.000 €</a:t>
+                        <a:t>1,0 Mio.</a:t>
                       </a:r>
                     </a:p>
                   </a:txBody>
@@ -17894,7 +17895,8 @@
                           </a:solidFill>
                           <a:latin typeface="AOK Bundesweit"/>
                         </a:rPr>
-                        <a:t>Internes Personal (5 J.)</a:t>
+                        <a:t>Internes Personal
+(5 J., ~6-10 FTE)</a:t>
                       </a:r>
                     </a:p>
                   </a:txBody>
@@ -17913,7 +17915,7 @@
                           </a:solidFill>
                           <a:latin typeface="AOK Bundesweit"/>
                         </a:rPr>
-                        <a:t>100.000 €</a:t>
+                        <a:t>3,0 Mio.</a:t>
                       </a:r>
                     </a:p>
                   </a:txBody>
@@ -17932,7 +17934,7 @@
                           </a:solidFill>
                           <a:latin typeface="AOK Bundesweit"/>
                         </a:rPr>
-                        <a:t>125.000 €</a:t>
+                        <a:t>4,0 Mio.</a:t>
                       </a:r>
                     </a:p>
                   </a:txBody>
@@ -17951,7 +17953,7 @@
                           </a:solidFill>
                           <a:latin typeface="AOK Bundesweit"/>
                         </a:rPr>
-                        <a:t>75.000 €</a:t>
+                        <a:t>2,5 Mio.</a:t>
                       </a:r>
                     </a:p>
                   </a:txBody>
@@ -17970,7 +17972,7 @@
                           </a:solidFill>
                           <a:latin typeface="AOK Bundesweit"/>
                         </a:rPr>
-                        <a:t>125.000 €</a:t>
+                        <a:t>4,0 Mio.</a:t>
                       </a:r>
                     </a:p>
                   </a:txBody>
@@ -17989,7 +17991,7 @@
                           </a:solidFill>
                           <a:latin typeface="AOK Bundesweit"/>
                         </a:rPr>
-                        <a:t>175.000 €</a:t>
+                        <a:t>5,0 Mio.</a:t>
                       </a:r>
                     </a:p>
                   </a:txBody>
@@ -18008,7 +18010,7 @@
                           </a:solidFill>
                           <a:latin typeface="AOK Bundesweit"/>
                         </a:rPr>
-                        <a:t>125.000 €</a:t>
+                        <a:t>3,5 Mio.</a:t>
                       </a:r>
                     </a:p>
                   </a:txBody>
@@ -18052,7 +18054,7 @@
                           </a:solidFill>
                           <a:latin typeface="AOK Bundesweit"/>
                         </a:rPr>
-                        <a:t>~255.000 €</a:t>
+                        <a:t>~9,8 Mio.</a:t>
                       </a:r>
                     </a:p>
                   </a:txBody>
@@ -18075,7 +18077,7 @@
                           </a:solidFill>
                           <a:latin typeface="AOK Bundesweit"/>
                         </a:rPr>
-                        <a:t>~625.000 €</a:t>
+                        <a:t>~28,5 Mio.</a:t>
                       </a:r>
                     </a:p>
                   </a:txBody>
@@ -18098,7 +18100,7 @@
                           </a:solidFill>
                           <a:latin typeface="AOK Bundesweit"/>
                         </a:rPr>
-                        <a:t>~620.000 €</a:t>
+                        <a:t>~29,8 Mio.</a:t>
                       </a:r>
                     </a:p>
                   </a:txBody>
@@ -18121,7 +18123,7 @@
                           </a:solidFill>
                           <a:latin typeface="AOK Bundesweit"/>
                         </a:rPr>
-                        <a:t>~675.000 €</a:t>
+                        <a:t>~34,0 Mio.</a:t>
                       </a:r>
                     </a:p>
                   </a:txBody>
@@ -18144,7 +18146,7 @@
                           </a:solidFill>
                           <a:latin typeface="AOK Bundesweit"/>
                         </a:rPr>
-                        <a:t>~370.000 €</a:t>
+                        <a:t>~16,5 Mio.</a:t>
                       </a:r>
                     </a:p>
                   </a:txBody>
@@ -18167,7 +18169,7 @@
                           </a:solidFill>
                           <a:latin typeface="AOK Bundesweit"/>
                         </a:rPr>
-                        <a:t>~325.000 €</a:t>
+                        <a:t>~15,5 Mio.</a:t>
                       </a:r>
                     </a:p>
                   </a:txBody>
@@ -18215,7 +18217,7 @@
                           </a:solidFill>
                           <a:latin typeface="AOK Bundesweit"/>
                         </a:rPr>
-                        <a:t>~510 €</a:t>
+                        <a:t>~280 €</a:t>
                       </a:r>
                     </a:p>
                   </a:txBody>
@@ -18238,7 +18240,7 @@
                           </a:solidFill>
                           <a:latin typeface="AOK Bundesweit"/>
                         </a:rPr>
-                        <a:t>~1.250 €</a:t>
+                        <a:t>~814 €</a:t>
                       </a:r>
                     </a:p>
                   </a:txBody>
@@ -18261,7 +18263,7 @@
                           </a:solidFill>
                           <a:latin typeface="AOK Bundesweit"/>
                         </a:rPr>
-                        <a:t>~1.240 €</a:t>
+                        <a:t>~851 €</a:t>
                       </a:r>
                     </a:p>
                   </a:txBody>
@@ -18284,7 +18286,7 @@
                           </a:solidFill>
                           <a:latin typeface="AOK Bundesweit"/>
                         </a:rPr>
-                        <a:t>~1.350 €</a:t>
+                        <a:t>~971 €</a:t>
                       </a:r>
                     </a:p>
                   </a:txBody>
@@ -18307,7 +18309,7 @@
                           </a:solidFill>
                           <a:latin typeface="AOK Bundesweit"/>
                         </a:rPr>
-                        <a:t>~740 €</a:t>
+                        <a:t>~471 €</a:t>
                       </a:r>
                     </a:p>
                   </a:txBody>
@@ -18330,7 +18332,7 @@
                           </a:solidFill>
                           <a:latin typeface="AOK Bundesweit"/>
                         </a:rPr>
-                        <a:t>~650 €</a:t>
+                        <a:t>~443 €</a:t>
                       </a:r>
                     </a:p>
                   </a:txBody>
@@ -19812,7 +19814,7 @@
                 </a:solidFill>
                 <a:latin typeface="AOK Bundesweit"/>
               </a:rPr>
-              <a:t> Bei VDI-Projekten wird der Schwellenwert über die Vertragslaufzeit (5 J.) fast immer überschritten → EU-weite Ausschreibung erforderlich</a:t>
+              <a:t> Bei 7.000 Desktops (TCO 10-34 Mio. €) ist eine EU-weite Ausschreibung zwingend erforderlich</a:t>
             </a:r>
           </a:p>
         </p:txBody>
@@ -20882,7 +20884,7 @@
                           </a:solidFill>
                           <a:latin typeface="AOK Bundesweit"/>
                         </a:rPr>
-                        <a:t>4</a:t>
+                        <a:t>5</a:t>
                       </a:r>
                     </a:p>
                   </a:txBody>
@@ -21162,7 +21164,7 @@
                           </a:solidFill>
                           <a:latin typeface="AOK Bundesweit"/>
                         </a:rPr>
-                        <a:t>5</a:t>
+                        <a:t>4</a:t>
                       </a:r>
                     </a:p>
                   </a:txBody>
@@ -21814,7 +21816,53 @@
                           </a:solidFill>
                           <a:latin typeface="AOK Bundesweit"/>
                         </a:rPr>
-                        <a:t>8</a:t>
+                        <a:t>6</a:t>
+                      </a:r>
+                    </a:p>
+                  </a:txBody>
+                  <a:tcPr anchor="ctr">
+                    <a:solidFill>
+                      <a:srgbClr val="E8F5E9"/>
+                    </a:solidFill>
+                  </a:tcPr>
+                </a:tc>
+                <a:tc>
+                  <a:txBody>
+                    <a:bodyPr wrap="square"/>
+                    <a:lstStyle/>
+                    <a:p>
+                      <a:pPr algn="ctr"/>
+                      <a:r>
+                        <a:rPr sz="1100" b="0">
+                          <a:solidFill>
+                            <a:srgbClr val="333333"/>
+                          </a:solidFill>
+                          <a:latin typeface="AOK Bundesweit"/>
+                        </a:rPr>
+                        <a:t>5</a:t>
+                      </a:r>
+                    </a:p>
+                  </a:txBody>
+                  <a:tcPr anchor="ctr">
+                    <a:solidFill>
+                      <a:srgbClr val="FFF3E0"/>
+                    </a:solidFill>
+                  </a:tcPr>
+                </a:tc>
+                <a:tc>
+                  <a:txBody>
+                    <a:bodyPr wrap="square"/>
+                    <a:lstStyle/>
+                    <a:p>
+                      <a:pPr algn="ctr"/>
+                      <a:r>
+                        <a:rPr sz="1100" b="0">
+                          <a:solidFill>
+                            <a:srgbClr val="333333"/>
+                          </a:solidFill>
+                          <a:latin typeface="AOK Bundesweit"/>
+                        </a:rPr>
+                        <a:t>9</a:t>
                       </a:r>
                     </a:p>
                   </a:txBody>
@@ -21860,53 +21908,7 @@
                           </a:solidFill>
                           <a:latin typeface="AOK Bundesweit"/>
                         </a:rPr>
-                        <a:t>9</a:t>
-                      </a:r>
-                    </a:p>
-                  </a:txBody>
-                  <a:tcPr anchor="ctr">
-                    <a:solidFill>
-                      <a:srgbClr val="C8E6C9"/>
-                    </a:solidFill>
-                  </a:tcPr>
-                </a:tc>
-                <a:tc>
-                  <a:txBody>
-                    <a:bodyPr wrap="square"/>
-                    <a:lstStyle/>
-                    <a:p>
-                      <a:pPr algn="ctr"/>
-                      <a:r>
-                        <a:rPr sz="1100" b="0">
-                          <a:solidFill>
-                            <a:srgbClr val="333333"/>
-                          </a:solidFill>
-                          <a:latin typeface="AOK Bundesweit"/>
-                        </a:rPr>
-                        <a:t>5</a:t>
-                      </a:r>
-                    </a:p>
-                  </a:txBody>
-                  <a:tcPr anchor="ctr">
-                    <a:solidFill>
-                      <a:srgbClr val="FFF3E0"/>
-                    </a:solidFill>
-                  </a:tcPr>
-                </a:tc>
-                <a:tc>
-                  <a:txBody>
-                    <a:bodyPr wrap="square"/>
-                    <a:lstStyle/>
-                    <a:p>
-                      <a:pPr algn="ctr"/>
-                      <a:r>
-                        <a:rPr sz="1100" b="0">
-                          <a:solidFill>
-                            <a:srgbClr val="333333"/>
-                          </a:solidFill>
-                          <a:latin typeface="AOK Bundesweit"/>
-                        </a:rPr>
-                        <a:t>3</a:t>
+                        <a:t>2</a:t>
                       </a:r>
                     </a:p>
                   </a:txBody>
@@ -21977,7 +21979,7 @@
                           </a:solidFill>
                           <a:latin typeface="AOK Bundesweit"/>
                         </a:rPr>
-                        <a:t>7,45</a:t>
+                        <a:t>7,25</a:t>
                       </a:r>
                     </a:p>
                   </a:txBody>
@@ -22000,7 +22002,7 @@
                           </a:solidFill>
                           <a:latin typeface="AOK Bundesweit"/>
                         </a:rPr>
-                        <a:t>6,25</a:t>
+                        <a:t>6,30</a:t>
                       </a:r>
                     </a:p>
                   </a:txBody>
@@ -22023,7 +22025,7 @@
                           </a:solidFill>
                           <a:latin typeface="AOK Bundesweit"/>
                         </a:rPr>
-                        <a:t>5,60</a:t>
+                        <a:t>5,90</a:t>
                       </a:r>
                     </a:p>
                   </a:txBody>
@@ -22046,7 +22048,7 @@
                           </a:solidFill>
                           <a:latin typeface="AOK Bundesweit"/>
                         </a:rPr>
-                        <a:t>5,35</a:t>
+                        <a:t>5,40</a:t>
                       </a:r>
                     </a:p>
                   </a:txBody>
@@ -22069,7 +22071,7 @@
                           </a:solidFill>
                           <a:latin typeface="AOK Bundesweit"/>
                         </a:rPr>
-                        <a:t>6,55</a:t>
+                        <a:t>6,75</a:t>
                       </a:r>
                     </a:p>
                   </a:txBody>
@@ -22170,7 +22172,7 @@
                 </a:solidFill>
                 <a:latin typeface="AOK Bundesweit"/>
               </a:rPr>
-              <a:t>— Bestes Gesamtpaket: Kosten, Datenschutz, Funktionalität</a:t>
+              <a:t>— Bestes Gesamtpaket: Kosten, Datenschutz, Skalierbarkeit — TCO ~15,5 Mio. €</a:t>
             </a:r>
           </a:p>
           <a:p>
@@ -22195,7 +22197,7 @@
                 </a:solidFill>
                 <a:latin typeface="AOK Bundesweit"/>
               </a:rPr>
-              <a:t>Windows RDS (7,45)  </a:t>
+              <a:t>Windows RDS (7,25)  </a:t>
             </a:r>
             <a:r>
               <a:rPr sz="1200" b="0">
@@ -22204,7 +22206,7 @@
                 </a:solidFill>
                 <a:latin typeface="AOK Bundesweit"/>
               </a:rPr>
-              <a:t>— Günstigste Lösung, aber keine echte VDI</a:t>
+              <a:t>— Günstigste Lösung (~9,8 Mio. €), aber sitzungsbasiert — keine echte VDI</a:t>
             </a:r>
           </a:p>
           <a:p>
@@ -22229,7 +22231,7 @@
                 </a:solidFill>
                 <a:latin typeface="AOK Bundesweit"/>
               </a:rPr>
-              <a:t>OpenDesktop (6,55)  </a:t>
+              <a:t>OpenDesktop (6,75)  </a:t>
             </a:r>
             <a:r>
               <a:rPr sz="1200" b="0">
@@ -22238,7 +22240,7 @@
                 </a:solidFill>
                 <a:latin typeface="AOK Bundesweit"/>
               </a:rPr>
-              <a:t>— Maximale Datensouveränität, hoher Personalaufwand</a:t>
+              <a:t>— Maximale Datensouveränität, aber ~10 FTE Personalaufwand</a:t>
             </a:r>
           </a:p>
           <a:p>
@@ -22263,7 +22265,7 @@
                 </a:solidFill>
                 <a:latin typeface="AOK Bundesweit"/>
               </a:rPr>
-              <a:t>Azure Local (6,25)  </a:t>
+              <a:t>Azure Local (6,30)  </a:t>
             </a:r>
             <a:r>
               <a:rPr sz="1200" b="0">
@@ -22272,7 +22274,7 @@
                 </a:solidFill>
                 <a:latin typeface="AOK Bundesweit"/>
               </a:rPr>
-              <a:t>— Guter Kompromiss, aber teuer und MS-abhängig</a:t>
+              <a:t>— Guter Kompromiss, aber ~28,5 Mio. € und starker MS-Lock-in</a:t>
             </a:r>
           </a:p>
           <a:p>
@@ -22297,7 +22299,7 @@
                 </a:solidFill>
                 <a:latin typeface="AOK Bundesweit"/>
               </a:rPr>
-              <a:t>Azure Virtual Desktop (5,60)  </a:t>
+              <a:t>Azure Virtual Desktop (5,90)  </a:t>
             </a:r>
             <a:r>
               <a:rPr sz="1200" b="0">
@@ -22306,7 +22308,7 @@
                 </a:solidFill>
                 <a:latin typeface="AOK Bundesweit"/>
               </a:rPr>
-              <a:t>— Technisch stark, Datenschutz kritisch</a:t>
+              <a:t>— Autoscaling-Vorteil bei 7.000 Usern, Datenschutz kritisch</a:t>
             </a:r>
           </a:p>
           <a:p>
@@ -22331,7 +22333,7 @@
                 </a:solidFill>
                 <a:latin typeface="AOK Bundesweit"/>
               </a:rPr>
-              <a:t>Omnissa Horizon (5,35)  </a:t>
+              <a:t>Omnissa Horizon (5,40)  </a:t>
             </a:r>
             <a:r>
               <a:rPr sz="1200" b="0">
@@ -22340,7 +22342,7 @@
                 </a:solidFill>
                 <a:latin typeface="AOK Bundesweit"/>
               </a:rPr>
-              <a:t>— Technisch ausgereift, Kosten-/KKR-Risiko</a:t>
+              <a:t>— Technisch ausgereift, aber teuerste Option (~34 Mio. €)</a:t>
             </a:r>
           </a:p>
         </p:txBody>
@@ -22451,7 +22453,7 @@
                 </a:solidFill>
                 <a:latin typeface="AOK Bundesweit"/>
               </a:rPr>
-              <a:t>Windows RDS als bewährte, kostengünstige Lösung für sitzungsbasierte Desktops</a:t>
+              <a:t>Windows RDS als bewährte Lösung — TCO ~9,8 Mio. € für 7.000 User, aber keine echte VDI und begrenzte Skalierungsfähigkeit (~100 RDS-Hosts nötig)</a:t>
             </a:r>
           </a:p>
           <a:p>
@@ -22470,7 +22472,7 @@
                 </a:solidFill>
                 <a:latin typeface="AOK Bundesweit"/>
               </a:rPr>
-              <a:t>Mittelfristig / VDI-Einstieg:</a:t>
+              <a:t>Empfehlung für 7.000 Desktops:</a:t>
             </a:r>
           </a:p>
           <a:p>
@@ -22486,7 +22488,7 @@
                 </a:solidFill>
                 <a:latin typeface="AOK Bundesweit"/>
               </a:rPr>
-              <a:t>Proxmox VE + UDS Enterprise als kosteneffiziente, datenschutzkonforme Lösung mit europäischen Herstellern</a:t>
+              <a:t>Proxmox VE + UDS Enterprise — TCO ~15,5 Mio. €, echte VDI, datenschutzkonform, EU-Hersteller; bei dieser Größenordnung der beste Kosten-Nutzen-Kompromiss</a:t>
             </a:r>
           </a:p>
           <a:p>
@@ -22521,7 +22523,7 @@
                 </a:solidFill>
                 <a:latin typeface="AOK Bundesweit"/>
               </a:rPr>
-              <a:t>Evaluierung einer Open-Source-Strategie (Proxmox/OpenDesktop) im Einklang mit der Digitalstrategie der öffentlichen Verwaltung</a:t>
+              <a:t>OpenDesktop-Ansatz als langfristige Open-Source-Strategie (~16,5 Mio. €), aber ~10 FTE nötig — nur mit entsprechendem Personalaufbau realistisch</a:t>
             </a:r>
           </a:p>
           <a:p>
@@ -22556,7 +22558,7 @@
                 </a:solidFill>
                 <a:latin typeface="AOK Bundesweit"/>
               </a:rPr>
-              <a:t>Omnissa Horizon (KKR-/vSphere-Kostenrisiko) und reine AVD-Cloud (Datenschutzrisiko) nur nach umfassender Risiko- und Kosten-Analyse; AVD ggf. über Delos Cloud evaluieren</a:t>
+              <a:t>Omnissa Horizon (~34 Mio. €) und AVD Cloud (~29,8 Mio. €) — erhebliches Kostenrisiko bei 7.000 Desktops; AVD zusätzlich Datenschutzrisiko (CLOUD Act)</a:t>
             </a:r>
           </a:p>
         </p:txBody>
@@ -22664,7 +22666,7 @@
                 </a:solidFill>
                 <a:latin typeface="AOK Bundesweit"/>
               </a:rPr>
-              <a:t>     Exakte Nutzerzahl, Anwendungslandschaft, Performance definieren</a:t>
+              <a:t>     7.000 Desktops: Nutzerprofile, Anwendungslandschaft, Performance-Klassen definieren</a:t>
             </a:r>
           </a:p>
           <a:p>
@@ -22856,7 +22858,7 @@
                 </a:solidFill>
                 <a:latin typeface="AOK Bundesweit"/>
               </a:rPr>
-              <a:t>     Sofern Schwellenwert überschritten (sehr wahrscheinlich)</a:t>
+              <a:t>     Bei 7.000 Desktops zwingend erforderlich (TCO &gt;&gt; Schwellenwert)</a:t>
             </a:r>
           </a:p>
         </p:txBody>
@@ -22957,7 +22959,7 @@
                 </a:solidFill>
                 <a:latin typeface="AOK Bundesweit"/>
               </a:rPr>
-              <a:t> Evaluierung geeigneter VDI-Lösungen für unsere öffentlich-rechtliche Einrichtung</a:t>
+              <a:t> Evaluierung geeigneter VDI-Lösungen für ~7.000 Desktops in unserer öffentlich-rechtlichen Einrichtung</a:t>
             </a:r>
           </a:p>
           <a:p>
@@ -24036,7 +24038,7 @@
                 </a:solidFill>
                 <a:latin typeface="AOK Bundesweit"/>
               </a:rPr>
-              <a:t>TCO 5J / 100 User: ~255.000 € (~510 €/User/Jahr)</a:t>
+              <a:t>TCO 5J / 7.000 User: ~9,8 Mio. € (~280 €/User/Jahr)</a:t>
             </a:r>
           </a:p>
         </p:txBody>
@@ -24336,7 +24338,7 @@
                 </a:solidFill>
                 <a:latin typeface="AOK Bundesweit"/>
               </a:rPr>
-              <a:t>TCO 5J / 100 User: ~625.000 € (~1.250 €/User/Jahr)</a:t>
+              <a:t>TCO 5J / 7.000 User: ~28,5 Mio. € (~814 €/User/Jahr)</a:t>
             </a:r>
           </a:p>
         </p:txBody>
@@ -24652,7 +24654,7 @@
                 </a:solidFill>
                 <a:latin typeface="AOK Bundesweit"/>
               </a:rPr>
-              <a:t>TCO 5J / 100 User: ~620.000 € (~1.240 €/User/Jahr)</a:t>
+              <a:t>TCO 5J / 7.000 User: ~29,8 Mio. € (~851 €/User/Jahr)</a:t>
             </a:r>
           </a:p>
         </p:txBody>
@@ -24984,7 +24986,7 @@
                 </a:solidFill>
                 <a:latin typeface="AOK Bundesweit"/>
               </a:rPr>
-              <a:t>TCO 5J / 100 User: ~675.000 € (~1.350 €/User/Jahr)</a:t>
+              <a:t>TCO 5J / 7.000 User: ~34,0 Mio. € (~971 €/User/Jahr)</a:t>
             </a:r>
           </a:p>
         </p:txBody>

</xml_diff>

<commit_message>
Add separate hardware cost section: PoC, migration, and GPU
Add section 5.1 to the analysis covering three additional hardware
cost blocks that must be budgeted separately from the main TCO:
- Test/PoC hardware (~65k-190k EUR) for evaluating 2-3 solutions
- Migration hardware for parallel operation (strategy-dependent)
- GPU requirements with cost estimates and per-solution support matrix

Also adds slide 15 to the presentation and updates next steps.

https://claude.ai/code/session_015mHD4NfjMbda5YrGvujwfD
</commit_message>
<xml_diff>
--- a/docs/VDI-Vergleichsanalyse.pptx
+++ b/docs/VDI-Vergleichsanalyse.pptx
@@ -36,6 +36,7 @@
     <p:sldId id="278" r:id="rId39"/>
     <p:sldId id="279" r:id="rId40"/>
     <p:sldId id="280" r:id="rId41"/>
+    <p:sldId id="281" r:id="rId42"/>
   </p:sldIdLst>
   <p:sldSz cx="12192000" cy="6858000"/>
   <p:notesSz cx="6858000" cy="9144000"/>
@@ -18367,12 +18368,12 @@
       <p:grpSpPr/>
       <p:sp>
         <p:nvSpPr>
-          <p:cNvPr id="2" name="Text Placeholder 1"/>
-          <p:cNvSpPr>
-            <a:spLocks noGrp="1"/>
-          </p:cNvSpPr>
-          <p:nvPr>
-            <p:ph type="body" idx="11" sz="quarter"/>
+          <p:cNvPr id="2" name="Title 1"/>
+          <p:cNvSpPr>
+            <a:spLocks noGrp="1"/>
+          </p:cNvSpPr>
+          <p:nvPr>
+            <p:ph type="title"/>
           </p:nvPr>
         </p:nvSpPr>
         <p:spPr/>
@@ -18381,19 +18382,19 @@
           <a:lstStyle/>
           <a:p>
             <a:r>
-              <a:t>DSGVO, BSI, Schrems-II, CLOUD Act</a:t>
-            </a:r>
-          </a:p>
-        </p:txBody>
-      </p:sp>
-      <p:sp>
-        <p:nvSpPr>
-          <p:cNvPr id="3" name="Title 2"/>
-          <p:cNvSpPr>
-            <a:spLocks noGrp="1"/>
-          </p:cNvSpPr>
-          <p:nvPr>
-            <p:ph type="title"/>
+              <a:t>Zusätzliche Hardware-Investitionen</a:t>
+            </a:r>
+          </a:p>
+        </p:txBody>
+      </p:sp>
+      <p:sp>
+        <p:nvSpPr>
+          <p:cNvPr id="3" name="Text Placeholder 2"/>
+          <p:cNvSpPr>
+            <a:spLocks noGrp="1"/>
+          </p:cNvSpPr>
+          <p:nvPr>
+            <p:ph type="body" idx="15" sz="quarter"/>
           </p:nvPr>
         </p:nvSpPr>
         <p:spPr/>
@@ -18402,31 +18403,495 @@
           <a:lstStyle/>
           <a:p>
             <a:r>
-              <a:t>Datenschutz und</a:t>
-            </a:r>
-          </a:p>
-          <a:p>
-            <a:r>
-              <a:t>IT-Sicherheit</a:t>
-            </a:r>
-          </a:p>
-        </p:txBody>
-      </p:sp>
-      <p:sp>
-        <p:nvSpPr>
-          <p:cNvPr id="4" name="Text Placeholder 3"/>
-          <p:cNvSpPr>
-            <a:spLocks noGrp="1"/>
-          </p:cNvSpPr>
-          <p:nvPr>
-            <p:ph type="body" idx="19" sz="quarter"/>
-          </p:nvPr>
-        </p:nvSpPr>
-        <p:spPr/>
-        <p:txBody>
-          <a:bodyPr/>
+              <a:t>Separat zu kalkulieren: Test-/PoC-Hardware, Migrations-Hardware, GPU-Ausstattung</a:t>
+            </a:r>
+          </a:p>
+        </p:txBody>
+      </p:sp>
+      <p:graphicFrame>
+        <p:nvGraphicFramePr>
+          <p:cNvPr id="4" name="Table 3"/>
+          <p:cNvGraphicFramePr>
+            <a:graphicFrameLocks noGrp="1"/>
+          </p:cNvGraphicFramePr>
+          <p:nvPr/>
+        </p:nvGraphicFramePr>
+        <p:xfrm>
+          <a:off x="540000" y="1260000"/>
+          <a:ext cx="9900000" cy="1872000"/>
+        </p:xfrm>
+        <a:graphic>
+          <a:graphicData uri="http://schemas.openxmlformats.org/drawingml/2006/table">
+            <a:tbl>
+              <a:tblPr firstRow="1" bandRow="1">
+                <a:tableStyleId>{5C22544A-7EE6-4342-B048-85BDC9FD1C3A}</a:tableStyleId>
+              </a:tblPr>
+              <a:tblGrid>
+                <a:gridCol w="1980000"/>
+                <a:gridCol w="3240000"/>
+                <a:gridCol w="2880000"/>
+                <a:gridCol w="1800000"/>
+              </a:tblGrid>
+              <a:tr h="468000">
+                <a:tc>
+                  <a:txBody>
+                    <a:bodyPr wrap="square"/>
+                    <a:lstStyle/>
+                    <a:p>
+                      <a:pPr algn="ctr"/>
+                      <a:r>
+                        <a:rPr sz="1000" b="1">
+                          <a:solidFill>
+                            <a:srgbClr val="FFFFFF"/>
+                          </a:solidFill>
+                          <a:latin typeface="AOK Bundesweit"/>
+                        </a:rPr>
+                        <a:t>Kostenblock</a:t>
+                      </a:r>
+                    </a:p>
+                  </a:txBody>
+                  <a:tcPr anchor="ctr">
+                    <a:solidFill>
+                      <a:srgbClr val="007B3E"/>
+                    </a:solidFill>
+                  </a:tcPr>
+                </a:tc>
+                <a:tc>
+                  <a:txBody>
+                    <a:bodyPr wrap="square"/>
+                    <a:lstStyle/>
+                    <a:p>
+                      <a:pPr algn="ctr"/>
+                      <a:r>
+                        <a:rPr sz="1000" b="1">
+                          <a:solidFill>
+                            <a:srgbClr val="FFFFFF"/>
+                          </a:solidFill>
+                          <a:latin typeface="AOK Bundesweit"/>
+                        </a:rPr>
+                        <a:t>Beschreibung</a:t>
+                      </a:r>
+                    </a:p>
+                  </a:txBody>
+                  <a:tcPr anchor="ctr">
+                    <a:solidFill>
+                      <a:srgbClr val="007B3E"/>
+                    </a:solidFill>
+                  </a:tcPr>
+                </a:tc>
+                <a:tc>
+                  <a:txBody>
+                    <a:bodyPr wrap="square"/>
+                    <a:lstStyle/>
+                    <a:p>
+                      <a:pPr algn="ctr"/>
+                      <a:r>
+                        <a:rPr sz="1000" b="1">
+                          <a:solidFill>
+                            <a:srgbClr val="FFFFFF"/>
+                          </a:solidFill>
+                          <a:latin typeface="AOK Bundesweit"/>
+                        </a:rPr>
+                        <a:t>Geschätzte Kosten</a:t>
+                      </a:r>
+                    </a:p>
+                  </a:txBody>
+                  <a:tcPr anchor="ctr">
+                    <a:solidFill>
+                      <a:srgbClr val="007B3E"/>
+                    </a:solidFill>
+                  </a:tcPr>
+                </a:tc>
+                <a:tc>
+                  <a:txBody>
+                    <a:bodyPr wrap="square"/>
+                    <a:lstStyle/>
+                    <a:p>
+                      <a:pPr algn="ctr"/>
+                      <a:r>
+                        <a:rPr sz="1000" b="1">
+                          <a:solidFill>
+                            <a:srgbClr val="FFFFFF"/>
+                          </a:solidFill>
+                          <a:latin typeface="AOK Bundesweit"/>
+                        </a:rPr>
+                        <a:t>Status</a:t>
+                      </a:r>
+                    </a:p>
+                  </a:txBody>
+                  <a:tcPr anchor="ctr">
+                    <a:solidFill>
+                      <a:srgbClr val="007B3E"/>
+                    </a:solidFill>
+                  </a:tcPr>
+                </a:tc>
+              </a:tr>
+              <a:tr h="468000">
+                <a:tc>
+                  <a:txBody>
+                    <a:bodyPr wrap="square"/>
+                    <a:lstStyle/>
+                    <a:p>
+                      <a:pPr algn="l"/>
+                      <a:r>
+                        <a:rPr sz="900" b="1">
+                          <a:solidFill>
+                            <a:srgbClr val="333333"/>
+                          </a:solidFill>
+                          <a:latin typeface="AOK Bundesweit"/>
+                        </a:rPr>
+                        <a:t>Test-/PoC-Hardware</a:t>
+                      </a:r>
+                    </a:p>
+                  </a:txBody>
+                  <a:tcPr anchor="ctr">
+                    <a:solidFill>
+                      <a:srgbClr val="F0F7F0"/>
+                    </a:solidFill>
+                  </a:tcPr>
+                </a:tc>
+                <a:tc>
+                  <a:txBody>
+                    <a:bodyPr wrap="square"/>
+                    <a:lstStyle/>
+                    <a:p>
+                      <a:pPr algn="l"/>
+                      <a:r>
+                        <a:rPr sz="900" b="0">
+                          <a:solidFill>
+                            <a:srgbClr val="333333"/>
+                          </a:solidFill>
+                          <a:latin typeface="AOK Bundesweit"/>
+                        </a:rPr>
+                        <a:t>Dedizierte Server (2–4 Hosts/Lösung),
+Storage, Netzwerk, Test-Endgeräte
+für PoC mit 2–3 Lösungen</a:t>
+                      </a:r>
+                    </a:p>
+                  </a:txBody>
+                  <a:tcPr anchor="ctr">
+                    <a:solidFill>
+                      <a:srgbClr val="F0F7F0"/>
+                    </a:solidFill>
+                  </a:tcPr>
+                </a:tc>
+                <a:tc>
+                  <a:txBody>
+                    <a:bodyPr wrap="square"/>
+                    <a:lstStyle/>
+                    <a:p>
+                      <a:pPr algn="r"/>
+                      <a:r>
+                        <a:rPr sz="900" b="1">
+                          <a:solidFill>
+                            <a:srgbClr val="333333"/>
+                          </a:solidFill>
+                          <a:latin typeface="AOK Bundesweit"/>
+                        </a:rPr>
+                        <a:t>65.000–190.000 €
+(einmalig, in Produktion
+überführbar)</a:t>
+                      </a:r>
+                    </a:p>
+                  </a:txBody>
+                  <a:tcPr anchor="ctr">
+                    <a:solidFill>
+                      <a:srgbClr val="F0F7F0"/>
+                    </a:solidFill>
+                  </a:tcPr>
+                </a:tc>
+                <a:tc>
+                  <a:txBody>
+                    <a:bodyPr wrap="square"/>
+                    <a:lstStyle/>
+                    <a:p>
+                      <a:pPr algn="ctr"/>
+                      <a:r>
+                        <a:rPr sz="900" b="1">
+                          <a:solidFill>
+                            <a:srgbClr val="E07C00"/>
+                          </a:solidFill>
+                          <a:latin typeface="AOK Bundesweit"/>
+                        </a:rPr>
+                        <a:t>Zu beschaffen</a:t>
+                      </a:r>
+                    </a:p>
+                  </a:txBody>
+                  <a:tcPr anchor="ctr">
+                    <a:solidFill>
+                      <a:srgbClr val="F0F7F0"/>
+                    </a:solidFill>
+                  </a:tcPr>
+                </a:tc>
+              </a:tr>
+              <a:tr h="468000">
+                <a:tc>
+                  <a:txBody>
+                    <a:bodyPr wrap="square"/>
+                    <a:lstStyle/>
+                    <a:p>
+                      <a:pPr algn="l"/>
+                      <a:r>
+                        <a:rPr sz="900" b="1">
+                          <a:solidFill>
+                            <a:srgbClr val="333333"/>
+                          </a:solidFill>
+                          <a:latin typeface="AOK Bundesweit"/>
+                        </a:rPr>
+                        <a:t>Migrations-Hardware
+(Parallelbetrieb)</a:t>
+                      </a:r>
+                    </a:p>
+                  </a:txBody>
+                  <a:tcPr anchor="ctr"/>
+                </a:tc>
+                <a:tc>
+                  <a:txBody>
+                    <a:bodyPr wrap="square"/>
+                    <a:lstStyle/>
+                    <a:p>
+                      <a:pPr algn="l"/>
+                      <a:r>
+                        <a:rPr sz="900" b="0">
+                          <a:solidFill>
+                            <a:srgbClr val="333333"/>
+                          </a:solidFill>
+                          <a:latin typeface="AOK Bundesweit"/>
+                        </a:rPr>
+                        <a:t>Zusätzliche Kapazität während
+Migration (Alt- + Neusystem parallel)
+Bei phasenweiser Migration: 15–30 %</a:t>
+                      </a:r>
+                    </a:p>
+                  </a:txBody>
+                  <a:tcPr anchor="ctr"/>
+                </a:tc>
+                <a:tc>
+                  <a:txBody>
+                    <a:bodyPr wrap="square"/>
+                    <a:lstStyle/>
+                    <a:p>
+                      <a:pPr algn="r"/>
+                      <a:r>
+                        <a:rPr sz="900" b="1">
+                          <a:solidFill>
+                            <a:srgbClr val="333333"/>
+                          </a:solidFill>
+                          <a:latin typeface="AOK Bundesweit"/>
+                        </a:rPr>
+                        <a:t>300.000–600.000 €
+(phasenweise, 7.000 User)
+Big Bang: 1,5–3,0 Mio. €</a:t>
+                      </a:r>
+                    </a:p>
+                  </a:txBody>
+                  <a:tcPr anchor="ctr"/>
+                </a:tc>
+                <a:tc>
+                  <a:txBody>
+                    <a:bodyPr wrap="square"/>
+                    <a:lstStyle/>
+                    <a:p>
+                      <a:pPr algn="ctr"/>
+                      <a:r>
+                        <a:rPr sz="900" b="1">
+                          <a:solidFill>
+                            <a:srgbClr val="C00000"/>
+                          </a:solidFill>
+                          <a:latin typeface="AOK Bundesweit"/>
+                        </a:rPr>
+                        <a:t>Menge noch zu
+bestimmen</a:t>
+                      </a:r>
+                    </a:p>
+                  </a:txBody>
+                  <a:tcPr anchor="ctr"/>
+                </a:tc>
+              </a:tr>
+              <a:tr h="468000">
+                <a:tc>
+                  <a:txBody>
+                    <a:bodyPr wrap="square"/>
+                    <a:lstStyle/>
+                    <a:p>
+                      <a:pPr algn="l"/>
+                      <a:r>
+                        <a:rPr sz="900" b="1">
+                          <a:solidFill>
+                            <a:srgbClr val="333333"/>
+                          </a:solidFill>
+                          <a:latin typeface="AOK Bundesweit"/>
+                        </a:rPr>
+                        <a:t>GPU-Hardware
+(falls benötigt)</a:t>
+                      </a:r>
+                    </a:p>
+                  </a:txBody>
+                  <a:tcPr anchor="ctr">
+                    <a:solidFill>
+                      <a:srgbClr val="F0F7F0"/>
+                    </a:solidFill>
+                  </a:tcPr>
+                </a:tc>
+                <a:tc>
+                  <a:txBody>
+                    <a:bodyPr wrap="square"/>
+                    <a:lstStyle/>
+                    <a:p>
+                      <a:pPr algn="l"/>
+                      <a:r>
+                        <a:rPr sz="900" b="0">
+                          <a:solidFill>
+                            <a:srgbClr val="333333"/>
+                          </a:solidFill>
+                          <a:latin typeface="AOK Bundesweit"/>
+                        </a:rPr>
+                        <a:t>vGPU-Karten (z.B. NVIDIA A16/L4)
++ GPU-fähige Server-Hosts
++ NVIDIA vGPU-Lizenzen</a:t>
+                      </a:r>
+                    </a:p>
+                  </a:txBody>
+                  <a:tcPr anchor="ctr">
+                    <a:solidFill>
+                      <a:srgbClr val="F0F7F0"/>
+                    </a:solidFill>
+                  </a:tcPr>
+                </a:tc>
+                <a:tc>
+                  <a:txBody>
+                    <a:bodyPr wrap="square"/>
+                    <a:lstStyle/>
+                    <a:p>
+                      <a:pPr algn="r"/>
+                      <a:r>
+                        <a:rPr sz="900" b="1">
+                          <a:solidFill>
+                            <a:srgbClr val="333333"/>
+                          </a:solidFill>
+                          <a:latin typeface="AOK Bundesweit"/>
+                        </a:rPr>
+                        <a:t>Bei 10 % GPU-Nutzern:
+~280.000–468.000 € (5 J.)
+Ohne GPU: 0 €</a:t>
+                      </a:r>
+                    </a:p>
+                  </a:txBody>
+                  <a:tcPr anchor="ctr">
+                    <a:solidFill>
+                      <a:srgbClr val="F0F7F0"/>
+                    </a:solidFill>
+                  </a:tcPr>
+                </a:tc>
+                <a:tc>
+                  <a:txBody>
+                    <a:bodyPr wrap="square"/>
+                    <a:lstStyle/>
+                    <a:p>
+                      <a:pPr algn="ctr"/>
+                      <a:r>
+                        <a:rPr sz="900" b="1">
+                          <a:solidFill>
+                            <a:srgbClr val="C00000"/>
+                          </a:solidFill>
+                          <a:latin typeface="AOK Bundesweit"/>
+                        </a:rPr>
+                        <a:t>Bedarfsanalyse
+erforderlich</a:t>
+                      </a:r>
+                    </a:p>
+                  </a:txBody>
+                  <a:tcPr anchor="ctr">
+                    <a:solidFill>
+                      <a:srgbClr val="F0F7F0"/>
+                    </a:solidFill>
+                  </a:tcPr>
+                </a:tc>
+              </a:tr>
+            </a:tbl>
+          </a:graphicData>
+        </a:graphic>
+      </p:graphicFrame>
+      <p:sp>
+        <p:nvSpPr>
+          <p:cNvPr id="5" name="TextBox 4"/>
+          <p:cNvSpPr txBox="1"/>
+          <p:nvPr/>
+        </p:nvSpPr>
+        <p:spPr>
+          <a:xfrm>
+            <a:off x="540000" y="3311999"/>
+            <a:ext cx="10980000" cy="900000"/>
+          </a:xfrm>
+          <a:prstGeom prst="rect">
+            <a:avLst/>
+          </a:prstGeom>
+          <a:noFill/>
+        </p:spPr>
+        <p:txBody>
+          <a:bodyPr wrap="square">
+            <a:spAutoFit/>
+          </a:bodyPr>
           <a:lstStyle/>
-          <a:p/>
+          <a:p>
+            <a:r>
+              <a:rPr sz="1100" b="1">
+                <a:solidFill>
+                  <a:srgbClr val="C00000"/>
+                </a:solidFill>
+                <a:latin typeface="AOK Bundesweit"/>
+              </a:rPr>
+              <a:t>Offene Fragen:</a:t>
+            </a:r>
+          </a:p>
+          <a:p>
+            <a:pPr>
+              <a:spcAft>
+                <a:spcPts val="200"/>
+              </a:spcAft>
+            </a:pPr>
+            <a:r>
+              <a:rPr sz="1000" b="0">
+                <a:solidFill>
+                  <a:srgbClr val="333333"/>
+                </a:solidFill>
+                <a:latin typeface="AOK Bundesweit"/>
+              </a:rPr>
+              <a:t>• Wird GPU-Power benötigt? → Benutzerprofilanalyse durchführen (CAD, GIS, PACS, Multimedia, KI)</a:t>
+            </a:r>
+          </a:p>
+          <a:p>
+            <a:pPr>
+              <a:spcAft>
+                <a:spcPts val="200"/>
+              </a:spcAft>
+            </a:pPr>
+            <a:r>
+              <a:rPr sz="1000" b="0">
+                <a:solidFill>
+                  <a:srgbClr val="333333"/>
+                </a:solidFill>
+                <a:latin typeface="AOK Bundesweit"/>
+              </a:rPr>
+              <a:t>• Welche Migrationsstrategie? → Bestimmt Menge der Migrations-Hardware (Big Bang vs. phasenweise)</a:t>
+            </a:r>
+          </a:p>
+          <a:p>
+            <a:pPr>
+              <a:spcAft>
+                <a:spcPts val="200"/>
+              </a:spcAft>
+            </a:pPr>
+            <a:r>
+              <a:rPr sz="1000" b="0">
+                <a:solidFill>
+                  <a:srgbClr val="333333"/>
+                </a:solidFill>
+                <a:latin typeface="AOK Bundesweit"/>
+              </a:rPr>
+              <a:t>• Kann PoC-Hardware in Produktion übernommen werden? → Bei Beschaffung auf Prod-Eignung achten</a:t>
+            </a:r>
+          </a:p>
         </p:txBody>
       </p:sp>
     </p:spTree>
@@ -18438,6 +18903,88 @@
 </file>
 
 <file path=ppt/slides/slide16.xml><?xml version="1.0" encoding="utf-8"?>
+<p:sld xmlns:a="http://schemas.openxmlformats.org/drawingml/2006/main" xmlns:p="http://schemas.openxmlformats.org/presentationml/2006/main" xmlns:r="http://schemas.openxmlformats.org/officeDocument/2006/relationships">
+  <p:cSld>
+    <p:spTree>
+      <p:nvGrpSpPr>
+        <p:cNvPr id="1" name=""/>
+        <p:cNvGrpSpPr/>
+        <p:nvPr/>
+      </p:nvGrpSpPr>
+      <p:grpSpPr/>
+      <p:sp>
+        <p:nvSpPr>
+          <p:cNvPr id="2" name="Text Placeholder 1"/>
+          <p:cNvSpPr>
+            <a:spLocks noGrp="1"/>
+          </p:cNvSpPr>
+          <p:nvPr>
+            <p:ph type="body" idx="11" sz="quarter"/>
+          </p:nvPr>
+        </p:nvSpPr>
+        <p:spPr/>
+        <p:txBody>
+          <a:bodyPr/>
+          <a:lstStyle/>
+          <a:p>
+            <a:r>
+              <a:t>DSGVO, BSI, Schrems-II, CLOUD Act</a:t>
+            </a:r>
+          </a:p>
+        </p:txBody>
+      </p:sp>
+      <p:sp>
+        <p:nvSpPr>
+          <p:cNvPr id="3" name="Title 2"/>
+          <p:cNvSpPr>
+            <a:spLocks noGrp="1"/>
+          </p:cNvSpPr>
+          <p:nvPr>
+            <p:ph type="title"/>
+          </p:nvPr>
+        </p:nvSpPr>
+        <p:spPr/>
+        <p:txBody>
+          <a:bodyPr/>
+          <a:lstStyle/>
+          <a:p>
+            <a:r>
+              <a:t>Datenschutz und</a:t>
+            </a:r>
+          </a:p>
+          <a:p>
+            <a:r>
+              <a:t>IT-Sicherheit</a:t>
+            </a:r>
+          </a:p>
+        </p:txBody>
+      </p:sp>
+      <p:sp>
+        <p:nvSpPr>
+          <p:cNvPr id="4" name="Text Placeholder 3"/>
+          <p:cNvSpPr>
+            <a:spLocks noGrp="1"/>
+          </p:cNvSpPr>
+          <p:nvPr>
+            <p:ph type="body" idx="19" sz="quarter"/>
+          </p:nvPr>
+        </p:nvSpPr>
+        <p:spPr/>
+        <p:txBody>
+          <a:bodyPr/>
+          <a:lstStyle/>
+          <a:p/>
+        </p:txBody>
+      </p:sp>
+    </p:spTree>
+  </p:cSld>
+  <p:clrMapOvr>
+    <a:masterClrMapping/>
+  </p:clrMapOvr>
+</p:sld>
+</file>
+
+<file path=ppt/slides/slide17.xml><?xml version="1.0" encoding="utf-8"?>
 <p:sld xmlns:a="http://schemas.openxmlformats.org/drawingml/2006/main" xmlns:p="http://schemas.openxmlformats.org/presentationml/2006/main" xmlns:r="http://schemas.openxmlformats.org/officeDocument/2006/relationships">
   <p:cSld>
     <p:spTree>
@@ -19280,271 +19827,6 @@
 </p:sld>
 </file>
 
-<file path=ppt/slides/slide17.xml><?xml version="1.0" encoding="utf-8"?>
-<p:sld xmlns:a="http://schemas.openxmlformats.org/drawingml/2006/main" xmlns:p="http://schemas.openxmlformats.org/presentationml/2006/main" xmlns:r="http://schemas.openxmlformats.org/officeDocument/2006/relationships">
-  <p:cSld>
-    <p:spTree>
-      <p:nvGrpSpPr>
-        <p:cNvPr id="1" name=""/>
-        <p:cNvGrpSpPr/>
-        <p:nvPr/>
-      </p:nvGrpSpPr>
-      <p:grpSpPr/>
-      <p:sp>
-        <p:nvSpPr>
-          <p:cNvPr id="2" name="Content Placeholder 1"/>
-          <p:cNvSpPr>
-            <a:spLocks noGrp="1"/>
-          </p:cNvSpPr>
-          <p:nvPr>
-            <p:ph idx="14" sz="quarter"/>
-          </p:nvPr>
-        </p:nvSpPr>
-        <p:spPr/>
-        <p:txBody>
-          <a:bodyPr/>
-          <a:lstStyle/>
-          <a:p>
-            <a:pPr>
-              <a:spcAft>
-                <a:spcPts val="600"/>
-              </a:spcAft>
-            </a:pPr>
-            <a:r>
-              <a:rPr sz="1200" b="1">
-                <a:solidFill>
-                  <a:srgbClr val="007B3E"/>
-                </a:solidFill>
-                <a:latin typeface="AOK Bundesweit"/>
-              </a:rPr>
-              <a:t>Bevorzugt:</a:t>
-            </a:r>
-            <a:r>
-              <a:rPr sz="1200" b="0">
-                <a:solidFill>
-                  <a:srgbClr val="333333"/>
-                </a:solidFill>
-                <a:latin typeface="AOK Bundesweit"/>
-              </a:rPr>
-              <a:t> On-Premises-Lösungen (RDS, Omnissa Horizon, Proxmox + UDS, OpenDesktop)</a:t>
-            </a:r>
-          </a:p>
-          <a:p>
-            <a:pPr>
-              <a:spcAft>
-                <a:spcPts val="600"/>
-              </a:spcAft>
-            </a:pPr>
-            <a:r>
-              <a:rPr sz="1200" b="1">
-                <a:solidFill>
-                  <a:srgbClr val="E07C00"/>
-                </a:solidFill>
-                <a:latin typeface="AOK Bundesweit"/>
-              </a:rPr>
-              <a:t>Bedingt geeignet:</a:t>
-            </a:r>
-            <a:r>
-              <a:rPr sz="1200" b="0">
-                <a:solidFill>
-                  <a:srgbClr val="333333"/>
-                </a:solidFill>
-                <a:latin typeface="AOK Bundesweit"/>
-              </a:rPr>
-              <a:t> Azure Local (Hybrid) — nach DSFA und mit organisatorischen Maßnahmen</a:t>
-            </a:r>
-          </a:p>
-          <a:p>
-            <a:pPr>
-              <a:spcAft>
-                <a:spcPts val="600"/>
-              </a:spcAft>
-            </a:pPr>
-            <a:r>
-              <a:rPr sz="1200" b="1">
-                <a:solidFill>
-                  <a:srgbClr val="C00000"/>
-                </a:solidFill>
-                <a:latin typeface="AOK Bundesweit"/>
-              </a:rPr>
-              <a:t>Kritisch:</a:t>
-            </a:r>
-            <a:r>
-              <a:rPr sz="1200" b="0">
-                <a:solidFill>
-                  <a:srgbClr val="333333"/>
-                </a:solidFill>
-                <a:latin typeface="AOK Bundesweit"/>
-              </a:rPr>
-              <a:t> AVD Cloud — nur nach umfassender DSFA und Genehmigung durch DSB</a:t>
-            </a:r>
-          </a:p>
-          <a:p>
-            <a:pPr>
-              <a:spcAft>
-                <a:spcPts val="400"/>
-              </a:spcAft>
-            </a:pPr>
-          </a:p>
-          <a:p>
-            <a:pPr>
-              <a:spcAft>
-                <a:spcPts val="600"/>
-              </a:spcAft>
-            </a:pPr>
-            <a:r>
-              <a:rPr sz="1200" b="1">
-                <a:solidFill>
-                  <a:srgbClr val="007B3E"/>
-                </a:solidFill>
-                <a:latin typeface="AOK Bundesweit"/>
-              </a:rPr>
-              <a:t>BSI C5:2025:</a:t>
-            </a:r>
-            <a:r>
-              <a:rPr sz="1200" b="0">
-                <a:solidFill>
-                  <a:srgbClr val="333333"/>
-                </a:solidFill>
-                <a:latin typeface="AOK Bundesweit"/>
-              </a:rPr>
-              <a:t> Erweiterte Kontrollen, Souveränitätskriterien — verpflichtend ab 01/2027</a:t>
-            </a:r>
-          </a:p>
-          <a:p>
-            <a:pPr>
-              <a:spcAft>
-                <a:spcPts val="600"/>
-              </a:spcAft>
-            </a:pPr>
-            <a:r>
-              <a:rPr sz="1200" b="1">
-                <a:solidFill>
-                  <a:srgbClr val="007B3E"/>
-                </a:solidFill>
-                <a:latin typeface="AOK Bundesweit"/>
-              </a:rPr>
-              <a:t>Delos Cloud:</a:t>
-            </a:r>
-            <a:r>
-              <a:rPr sz="1200" b="0">
-                <a:solidFill>
-                  <a:srgbClr val="333333"/>
-                </a:solidFill>
-                <a:latin typeface="AOK Bundesweit"/>
-              </a:rPr>
-              <a:t> Souveräne Azure-Alternative unter deutscher Betriebsführung (SAP/Delos GmbH)</a:t>
-            </a:r>
-          </a:p>
-          <a:p>
-            <a:pPr>
-              <a:spcAft>
-                <a:spcPts val="600"/>
-              </a:spcAft>
-            </a:pPr>
-            <a:r>
-              <a:rPr sz="1200" b="1">
-                <a:solidFill>
-                  <a:srgbClr val="007B3E"/>
-                </a:solidFill>
-                <a:latin typeface="AOK Bundesweit"/>
-              </a:rPr>
-              <a:t>DVC:</a:t>
-            </a:r>
-            <a:r>
-              <a:rPr sz="1200" b="0">
-                <a:solidFill>
-                  <a:srgbClr val="333333"/>
-                </a:solidFill>
-                <a:latin typeface="AOK Bundesweit"/>
-              </a:rPr>
-              <a:t> Deutsche Verwaltungscloud seit 04/2025 produktiv — vereinfachte Beschaffung</a:t>
-            </a:r>
-          </a:p>
-          <a:p>
-            <a:pPr>
-              <a:spcAft>
-                <a:spcPts val="400"/>
-              </a:spcAft>
-            </a:pPr>
-          </a:p>
-          <a:p>
-            <a:pPr>
-              <a:spcAft>
-                <a:spcPts val="600"/>
-              </a:spcAft>
-            </a:pPr>
-            <a:r>
-              <a:rPr sz="1200" b="1">
-                <a:solidFill>
-                  <a:srgbClr val="C00000"/>
-                </a:solidFill>
-                <a:latin typeface="AOK Bundesweit"/>
-              </a:rPr>
-              <a:t>Landesdatenschutzbeauftragte:</a:t>
-            </a:r>
-            <a:r>
-              <a:rPr sz="1200" b="0">
-                <a:solidFill>
-                  <a:srgbClr val="333333"/>
-                </a:solidFill>
-                <a:latin typeface="AOK Bundesweit"/>
-              </a:rPr>
-              <a:t> Einsatz von MS 365/Azure in öffentl. Verwaltung als problematisch eingestuft</a:t>
-            </a:r>
-          </a:p>
-        </p:txBody>
-      </p:sp>
-      <p:sp>
-        <p:nvSpPr>
-          <p:cNvPr id="3" name="Text Placeholder 2"/>
-          <p:cNvSpPr>
-            <a:spLocks noGrp="1"/>
-          </p:cNvSpPr>
-          <p:nvPr>
-            <p:ph type="body" idx="15" sz="quarter"/>
-          </p:nvPr>
-        </p:nvSpPr>
-        <p:spPr/>
-        <p:txBody>
-          <a:bodyPr/>
-          <a:lstStyle/>
-          <a:p>
-            <a:r>
-              <a:t>Regulatorischer Rahmen für öffentlich-rechtliche Einrichtungen</a:t>
-            </a:r>
-          </a:p>
-        </p:txBody>
-      </p:sp>
-      <p:sp>
-        <p:nvSpPr>
-          <p:cNvPr id="4" name="Title 3"/>
-          <p:cNvSpPr>
-            <a:spLocks noGrp="1"/>
-          </p:cNvSpPr>
-          <p:nvPr>
-            <p:ph type="title"/>
-          </p:nvPr>
-        </p:nvSpPr>
-        <p:spPr/>
-        <p:txBody>
-          <a:bodyPr/>
-          <a:lstStyle/>
-          <a:p>
-            <a:r>
-              <a:t>Datenschutz — Empfehlungen und Rahmenbedingungen</a:t>
-            </a:r>
-          </a:p>
-        </p:txBody>
-      </p:sp>
-    </p:spTree>
-  </p:cSld>
-  <p:clrMapOvr>
-    <a:masterClrMapping/>
-  </p:clrMapOvr>
-</p:sld>
-</file>
-
 <file path=ppt/slides/slide18.xml><?xml version="1.0" encoding="utf-8"?>
 <p:sld xmlns:a="http://schemas.openxmlformats.org/drawingml/2006/main" xmlns:p="http://schemas.openxmlformats.org/presentationml/2006/main" xmlns:r="http://schemas.openxmlformats.org/officeDocument/2006/relationships">
   <p:cSld>
@@ -19557,12 +19839,12 @@
       <p:grpSpPr/>
       <p:sp>
         <p:nvSpPr>
-          <p:cNvPr id="2" name="Text Placeholder 1"/>
-          <p:cNvSpPr>
-            <a:spLocks noGrp="1"/>
-          </p:cNvSpPr>
-          <p:nvPr>
-            <p:ph type="body" idx="11" sz="quarter"/>
+          <p:cNvPr id="2" name="Content Placeholder 1"/>
+          <p:cNvSpPr>
+            <a:spLocks noGrp="1"/>
+          </p:cNvSpPr>
+          <p:nvPr>
+            <p:ph idx="14" sz="quarter"/>
           </p:nvPr>
         </p:nvSpPr>
         <p:spPr/>
@@ -19570,20 +19852,204 @@
           <a:bodyPr/>
           <a:lstStyle/>
           <a:p>
-            <a:r>
-              <a:t>EU-Schwellenwerte, VgV, UVgO, EVB-IT</a:t>
-            </a:r>
-          </a:p>
-        </p:txBody>
-      </p:sp>
-      <p:sp>
-        <p:nvSpPr>
-          <p:cNvPr id="3" name="Title 2"/>
-          <p:cNvSpPr>
-            <a:spLocks noGrp="1"/>
-          </p:cNvSpPr>
-          <p:nvPr>
-            <p:ph type="title"/>
+            <a:pPr>
+              <a:spcAft>
+                <a:spcPts val="600"/>
+              </a:spcAft>
+            </a:pPr>
+            <a:r>
+              <a:rPr sz="1200" b="1">
+                <a:solidFill>
+                  <a:srgbClr val="007B3E"/>
+                </a:solidFill>
+                <a:latin typeface="AOK Bundesweit"/>
+              </a:rPr>
+              <a:t>Bevorzugt:</a:t>
+            </a:r>
+            <a:r>
+              <a:rPr sz="1200" b="0">
+                <a:solidFill>
+                  <a:srgbClr val="333333"/>
+                </a:solidFill>
+                <a:latin typeface="AOK Bundesweit"/>
+              </a:rPr>
+              <a:t> On-Premises-Lösungen (RDS, Omnissa Horizon, Proxmox + UDS, OpenDesktop)</a:t>
+            </a:r>
+          </a:p>
+          <a:p>
+            <a:pPr>
+              <a:spcAft>
+                <a:spcPts val="600"/>
+              </a:spcAft>
+            </a:pPr>
+            <a:r>
+              <a:rPr sz="1200" b="1">
+                <a:solidFill>
+                  <a:srgbClr val="E07C00"/>
+                </a:solidFill>
+                <a:latin typeface="AOK Bundesweit"/>
+              </a:rPr>
+              <a:t>Bedingt geeignet:</a:t>
+            </a:r>
+            <a:r>
+              <a:rPr sz="1200" b="0">
+                <a:solidFill>
+                  <a:srgbClr val="333333"/>
+                </a:solidFill>
+                <a:latin typeface="AOK Bundesweit"/>
+              </a:rPr>
+              <a:t> Azure Local (Hybrid) — nach DSFA und mit organisatorischen Maßnahmen</a:t>
+            </a:r>
+          </a:p>
+          <a:p>
+            <a:pPr>
+              <a:spcAft>
+                <a:spcPts val="600"/>
+              </a:spcAft>
+            </a:pPr>
+            <a:r>
+              <a:rPr sz="1200" b="1">
+                <a:solidFill>
+                  <a:srgbClr val="C00000"/>
+                </a:solidFill>
+                <a:latin typeface="AOK Bundesweit"/>
+              </a:rPr>
+              <a:t>Kritisch:</a:t>
+            </a:r>
+            <a:r>
+              <a:rPr sz="1200" b="0">
+                <a:solidFill>
+                  <a:srgbClr val="333333"/>
+                </a:solidFill>
+                <a:latin typeface="AOK Bundesweit"/>
+              </a:rPr>
+              <a:t> AVD Cloud — nur nach umfassender DSFA und Genehmigung durch DSB</a:t>
+            </a:r>
+          </a:p>
+          <a:p>
+            <a:pPr>
+              <a:spcAft>
+                <a:spcPts val="400"/>
+              </a:spcAft>
+            </a:pPr>
+          </a:p>
+          <a:p>
+            <a:pPr>
+              <a:spcAft>
+                <a:spcPts val="600"/>
+              </a:spcAft>
+            </a:pPr>
+            <a:r>
+              <a:rPr sz="1200" b="1">
+                <a:solidFill>
+                  <a:srgbClr val="007B3E"/>
+                </a:solidFill>
+                <a:latin typeface="AOK Bundesweit"/>
+              </a:rPr>
+              <a:t>BSI C5:2025:</a:t>
+            </a:r>
+            <a:r>
+              <a:rPr sz="1200" b="0">
+                <a:solidFill>
+                  <a:srgbClr val="333333"/>
+                </a:solidFill>
+                <a:latin typeface="AOK Bundesweit"/>
+              </a:rPr>
+              <a:t> Erweiterte Kontrollen, Souveränitätskriterien — verpflichtend ab 01/2027</a:t>
+            </a:r>
+          </a:p>
+          <a:p>
+            <a:pPr>
+              <a:spcAft>
+                <a:spcPts val="600"/>
+              </a:spcAft>
+            </a:pPr>
+            <a:r>
+              <a:rPr sz="1200" b="1">
+                <a:solidFill>
+                  <a:srgbClr val="007B3E"/>
+                </a:solidFill>
+                <a:latin typeface="AOK Bundesweit"/>
+              </a:rPr>
+              <a:t>Delos Cloud:</a:t>
+            </a:r>
+            <a:r>
+              <a:rPr sz="1200" b="0">
+                <a:solidFill>
+                  <a:srgbClr val="333333"/>
+                </a:solidFill>
+                <a:latin typeface="AOK Bundesweit"/>
+              </a:rPr>
+              <a:t> Souveräne Azure-Alternative unter deutscher Betriebsführung (SAP/Delos GmbH)</a:t>
+            </a:r>
+          </a:p>
+          <a:p>
+            <a:pPr>
+              <a:spcAft>
+                <a:spcPts val="600"/>
+              </a:spcAft>
+            </a:pPr>
+            <a:r>
+              <a:rPr sz="1200" b="1">
+                <a:solidFill>
+                  <a:srgbClr val="007B3E"/>
+                </a:solidFill>
+                <a:latin typeface="AOK Bundesweit"/>
+              </a:rPr>
+              <a:t>DVC:</a:t>
+            </a:r>
+            <a:r>
+              <a:rPr sz="1200" b="0">
+                <a:solidFill>
+                  <a:srgbClr val="333333"/>
+                </a:solidFill>
+                <a:latin typeface="AOK Bundesweit"/>
+              </a:rPr>
+              <a:t> Deutsche Verwaltungscloud seit 04/2025 produktiv — vereinfachte Beschaffung</a:t>
+            </a:r>
+          </a:p>
+          <a:p>
+            <a:pPr>
+              <a:spcAft>
+                <a:spcPts val="400"/>
+              </a:spcAft>
+            </a:pPr>
+          </a:p>
+          <a:p>
+            <a:pPr>
+              <a:spcAft>
+                <a:spcPts val="600"/>
+              </a:spcAft>
+            </a:pPr>
+            <a:r>
+              <a:rPr sz="1200" b="1">
+                <a:solidFill>
+                  <a:srgbClr val="C00000"/>
+                </a:solidFill>
+                <a:latin typeface="AOK Bundesweit"/>
+              </a:rPr>
+              <a:t>Landesdatenschutzbeauftragte:</a:t>
+            </a:r>
+            <a:r>
+              <a:rPr sz="1200" b="0">
+                <a:solidFill>
+                  <a:srgbClr val="333333"/>
+                </a:solidFill>
+                <a:latin typeface="AOK Bundesweit"/>
+              </a:rPr>
+              <a:t> Einsatz von MS 365/Azure in öffentl. Verwaltung als problematisch eingestuft</a:t>
+            </a:r>
+          </a:p>
+        </p:txBody>
+      </p:sp>
+      <p:sp>
+        <p:nvSpPr>
+          <p:cNvPr id="3" name="Text Placeholder 2"/>
+          <p:cNvSpPr>
+            <a:spLocks noGrp="1"/>
+          </p:cNvSpPr>
+          <p:nvPr>
+            <p:ph type="body" idx="15" sz="quarter"/>
           </p:nvPr>
         </p:nvSpPr>
         <p:spPr/>
@@ -19592,31 +20058,30 @@
           <a:lstStyle/>
           <a:p>
             <a:r>
-              <a:t>Vergaberechtliche</a:t>
-            </a:r>
-          </a:p>
-          <a:p>
-            <a:r>
-              <a:t>Aspekte</a:t>
-            </a:r>
-          </a:p>
-        </p:txBody>
-      </p:sp>
-      <p:sp>
-        <p:nvSpPr>
-          <p:cNvPr id="4" name="Text Placeholder 3"/>
-          <p:cNvSpPr>
-            <a:spLocks noGrp="1"/>
-          </p:cNvSpPr>
-          <p:nvPr>
-            <p:ph type="body" idx="19" sz="quarter"/>
+              <a:t>Regulatorischer Rahmen für öffentlich-rechtliche Einrichtungen</a:t>
+            </a:r>
+          </a:p>
+        </p:txBody>
+      </p:sp>
+      <p:sp>
+        <p:nvSpPr>
+          <p:cNvPr id="4" name="Title 3"/>
+          <p:cNvSpPr>
+            <a:spLocks noGrp="1"/>
+          </p:cNvSpPr>
+          <p:nvPr>
+            <p:ph type="title"/>
           </p:nvPr>
         </p:nvSpPr>
         <p:spPr/>
         <p:txBody>
           <a:bodyPr/>
           <a:lstStyle/>
-          <a:p/>
+          <a:p>
+            <a:r>
+              <a:t>Datenschutz — Empfehlungen und Rahmenbedingungen</a:t>
+            </a:r>
+          </a:p>
         </p:txBody>
       </p:sp>
     </p:spTree>
@@ -19639,12 +20104,12 @@
       <p:grpSpPr/>
       <p:sp>
         <p:nvSpPr>
-          <p:cNvPr id="2" name="Content Placeholder 1"/>
-          <p:cNvSpPr>
-            <a:spLocks noGrp="1"/>
-          </p:cNvSpPr>
-          <p:nvPr>
-            <p:ph idx="16" sz="quarter"/>
+          <p:cNvPr id="2" name="Text Placeholder 1"/>
+          <p:cNvSpPr>
+            <a:spLocks noGrp="1"/>
+          </p:cNvSpPr>
+          <p:nvPr>
+            <p:ph type="body" idx="11" sz="quarter"/>
           </p:nvPr>
         </p:nvSpPr>
         <p:spPr/>
@@ -19653,180 +20118,19 @@
           <a:lstStyle/>
           <a:p>
             <a:r>
-              <a:rPr sz="1300" b="1">
-                <a:solidFill>
-                  <a:srgbClr val="007B3E"/>
-                </a:solidFill>
-                <a:latin typeface="AOK Bundesweit"/>
-              </a:rPr>
-              <a:t>EU-Schwellenwerte (netto)</a:t>
-            </a:r>
-          </a:p>
-          <a:p>
-            <a:pPr>
-              <a:spcAft>
-                <a:spcPts val="400"/>
-              </a:spcAft>
-            </a:pPr>
-            <a:r>
-              <a:rPr sz="1100" b="1">
-                <a:solidFill>
-                  <a:srgbClr val="333333"/>
-                </a:solidFill>
-                <a:latin typeface="AOK Bundesweit"/>
-              </a:rPr>
-              <a:t>Bundesbehörden:</a:t>
-            </a:r>
-            <a:r>
-              <a:rPr sz="1100" b="0">
-                <a:solidFill>
-                  <a:srgbClr val="333333"/>
-                </a:solidFill>
-                <a:latin typeface="AOK Bundesweit"/>
-              </a:rPr>
-              <a:t> 140.000 €</a:t>
-            </a:r>
-          </a:p>
-          <a:p>
-            <a:pPr>
-              <a:spcAft>
-                <a:spcPts val="400"/>
-              </a:spcAft>
-            </a:pPr>
-            <a:r>
-              <a:rPr sz="1100" b="1">
-                <a:solidFill>
-                  <a:srgbClr val="333333"/>
-                </a:solidFill>
-                <a:latin typeface="AOK Bundesweit"/>
-              </a:rPr>
-              <a:t>Sonstige öffentl. AG:</a:t>
-            </a:r>
-            <a:r>
-              <a:rPr sz="1100" b="0">
-                <a:solidFill>
-                  <a:srgbClr val="333333"/>
-                </a:solidFill>
-                <a:latin typeface="AOK Bundesweit"/>
-              </a:rPr>
-              <a:t> 216.000 €</a:t>
-            </a:r>
-          </a:p>
-          <a:p>
-            <a:pPr>
-              <a:spcAft>
-                <a:spcPts val="400"/>
-              </a:spcAft>
-            </a:pPr>
-            <a:r>
-              <a:rPr sz="1100" b="1">
-                <a:solidFill>
-                  <a:srgbClr val="333333"/>
-                </a:solidFill>
-                <a:latin typeface="AOK Bundesweit"/>
-              </a:rPr>
-              <a:t>Sektorenauftraggeber:</a:t>
-            </a:r>
-            <a:r>
-              <a:rPr sz="1100" b="0">
-                <a:solidFill>
-                  <a:srgbClr val="333333"/>
-                </a:solidFill>
-                <a:latin typeface="AOK Bundesweit"/>
-              </a:rPr>
-              <a:t> 432.000 €</a:t>
-            </a:r>
-          </a:p>
-          <a:p>
-            <a:pPr>
-              <a:spcAft>
-                <a:spcPts val="400"/>
-              </a:spcAft>
-            </a:pPr>
-          </a:p>
-          <a:p>
-            <a:pPr>
-              <a:spcAft>
-                <a:spcPts val="400"/>
-              </a:spcAft>
-            </a:pPr>
-            <a:r>
-              <a:rPr sz="1100" b="1">
-                <a:solidFill>
-                  <a:srgbClr val="333333"/>
-                </a:solidFill>
-                <a:latin typeface="AOK Bundesweit"/>
-              </a:rPr>
-              <a:t>Unterschwellenbereich (UVgO):</a:t>
-            </a:r>
-          </a:p>
-          <a:p>
-            <a:pPr>
-              <a:spcAft>
-                <a:spcPts val="400"/>
-              </a:spcAft>
-            </a:pPr>
-            <a:r>
-              <a:rPr sz="1100" b="1">
-                <a:solidFill>
-                  <a:srgbClr val="333333"/>
-                </a:solidFill>
-                <a:latin typeface="AOK Bundesweit"/>
-              </a:rPr>
-              <a:t>Direktvergabe:</a:t>
-            </a:r>
-            <a:r>
-              <a:rPr sz="1100" b="0">
-                <a:solidFill>
-                  <a:srgbClr val="333333"/>
-                </a:solidFill>
-                <a:latin typeface="AOK Bundesweit"/>
-              </a:rPr>
-              <a:t> bis 100.000 € möglich</a:t>
-            </a:r>
-          </a:p>
-          <a:p>
-            <a:pPr>
-              <a:spcAft>
-                <a:spcPts val="400"/>
-              </a:spcAft>
-            </a:pPr>
-          </a:p>
-          <a:p>
-            <a:pPr>
-              <a:spcAft>
-                <a:spcPts val="400"/>
-              </a:spcAft>
-            </a:pPr>
-            <a:r>
-              <a:rPr sz="1100" b="1">
-                <a:solidFill>
-                  <a:srgbClr val="333333"/>
-                </a:solidFill>
-                <a:latin typeface="AOK Bundesweit"/>
-              </a:rPr>
-              <a:t>Praxis:</a:t>
-            </a:r>
-            <a:r>
-              <a:rPr sz="1100" b="0">
-                <a:solidFill>
-                  <a:srgbClr val="333333"/>
-                </a:solidFill>
-                <a:latin typeface="AOK Bundesweit"/>
-              </a:rPr>
-              <a:t> Bei 7.000 Desktops (TCO 10-34 Mio. €) ist eine EU-weite Ausschreibung zwingend erforderlich</a:t>
-            </a:r>
-          </a:p>
-        </p:txBody>
-      </p:sp>
-      <p:sp>
-        <p:nvSpPr>
-          <p:cNvPr id="3" name="Content Placeholder 2"/>
-          <p:cNvSpPr>
-            <a:spLocks noGrp="1"/>
-          </p:cNvSpPr>
-          <p:nvPr>
-            <p:ph idx="17" sz="quarter"/>
+              <a:t>EU-Schwellenwerte, VgV, UVgO, EVB-IT</a:t>
+            </a:r>
+          </a:p>
+        </p:txBody>
+      </p:sp>
+      <p:sp>
+        <p:nvSpPr>
+          <p:cNvPr id="3" name="Title 2"/>
+          <p:cNvSpPr>
+            <a:spLocks noGrp="1"/>
+          </p:cNvSpPr>
+          <p:nvPr>
+            <p:ph type="title"/>
           </p:nvPr>
         </p:nvSpPr>
         <p:spPr/>
@@ -19835,176 +20139,31 @@
           <a:lstStyle/>
           <a:p>
             <a:r>
-              <a:rPr sz="1300" b="1">
-                <a:solidFill>
-                  <a:srgbClr val="007B3E"/>
-                </a:solidFill>
-                <a:latin typeface="AOK Bundesweit"/>
-              </a:rPr>
-              <a:t>EVB-IT Vertragstypen</a:t>
-            </a:r>
-          </a:p>
-          <a:p>
-            <a:pPr>
-              <a:spcAft>
-                <a:spcPts val="400"/>
-              </a:spcAft>
-            </a:pPr>
-            <a:r>
-              <a:rPr sz="1000" b="0">
-                <a:solidFill>
-                  <a:srgbClr val="333333"/>
-                </a:solidFill>
-                <a:latin typeface="AOK Bundesweit"/>
-              </a:rPr>
-              <a:t>EVB-IT System — On-Premises VDI + Hardware</a:t>
-            </a:r>
-          </a:p>
-          <a:p>
-            <a:pPr>
-              <a:spcAft>
-                <a:spcPts val="400"/>
-              </a:spcAft>
-            </a:pPr>
-            <a:r>
-              <a:rPr sz="1000" b="0">
-                <a:solidFill>
-                  <a:srgbClr val="333333"/>
-                </a:solidFill>
-                <a:latin typeface="AOK Bundesweit"/>
-              </a:rPr>
-              <a:t>EVB-IT Cloud — Cloud-VDI (AVD, Azure Local); C5-Testat erforderlich</a:t>
-            </a:r>
-          </a:p>
-          <a:p>
-            <a:pPr>
-              <a:spcAft>
-                <a:spcPts val="400"/>
-              </a:spcAft>
-            </a:pPr>
-            <a:r>
-              <a:rPr sz="1000" b="0">
-                <a:solidFill>
-                  <a:srgbClr val="333333"/>
-                </a:solidFill>
-                <a:latin typeface="AOK Bundesweit"/>
-              </a:rPr>
-              <a:t>EVB-IT Überlassung Typ B — Softwarelizenzen (z.B. UDS Enterprise)</a:t>
-            </a:r>
-          </a:p>
-          <a:p>
-            <a:pPr>
-              <a:spcAft>
-                <a:spcPts val="400"/>
-              </a:spcAft>
-            </a:pPr>
-            <a:r>
-              <a:rPr sz="1000" b="0">
-                <a:solidFill>
-                  <a:srgbClr val="333333"/>
-                </a:solidFill>
-                <a:latin typeface="AOK Bundesweit"/>
-              </a:rPr>
-              <a:t>EVB-IT Pflege S — Wartung und Patching</a:t>
-            </a:r>
-          </a:p>
-          <a:p>
-            <a:pPr>
-              <a:spcAft>
-                <a:spcPts val="400"/>
-              </a:spcAft>
-            </a:pPr>
-            <a:r>
-              <a:rPr sz="1000" b="0">
-                <a:solidFill>
-                  <a:srgbClr val="333333"/>
-                </a:solidFill>
-                <a:latin typeface="AOK Bundesweit"/>
-              </a:rPr>
-              <a:t>EVB-IT Dienstvertrag — Implementierung/Beratung</a:t>
-            </a:r>
-          </a:p>
-          <a:p>
-            <a:pPr>
-              <a:spcAft>
-                <a:spcPts val="400"/>
-              </a:spcAft>
-            </a:pPr>
-            <a:r>
-              <a:rPr sz="1000" b="0">
-                <a:solidFill>
-                  <a:srgbClr val="333333"/>
-                </a:solidFill>
-                <a:latin typeface="AOK Bundesweit"/>
-              </a:rPr>
-              <a:t>EVB-IT Rahmenvereinbarung — Modulare VDI-Leistungen</a:t>
-            </a:r>
-          </a:p>
-          <a:p>
-            <a:pPr>
-              <a:spcAft>
-                <a:spcPts val="400"/>
-              </a:spcAft>
-            </a:pPr>
-          </a:p>
-          <a:p>
-            <a:pPr>
-              <a:spcAft>
-                <a:spcPts val="400"/>
-              </a:spcAft>
-            </a:pPr>
-            <a:r>
-              <a:rPr sz="1000" b="1">
-                <a:solidFill>
-                  <a:srgbClr val="C00000"/>
-                </a:solidFill>
-                <a:latin typeface="AOK Bundesweit"/>
-              </a:rPr>
-              <a:t>Pflicht: EVB-IT für Bundesbehörden (§ 55 BHO)</a:t>
-            </a:r>
-          </a:p>
-        </p:txBody>
-      </p:sp>
-      <p:sp>
-        <p:nvSpPr>
-          <p:cNvPr id="4" name="Title 3"/>
-          <p:cNvSpPr>
-            <a:spLocks noGrp="1"/>
-          </p:cNvSpPr>
-          <p:nvPr>
-            <p:ph type="title"/>
+              <a:t>Vergaberechtliche</a:t>
+            </a:r>
+          </a:p>
+          <a:p>
+            <a:r>
+              <a:t>Aspekte</a:t>
+            </a:r>
+          </a:p>
+        </p:txBody>
+      </p:sp>
+      <p:sp>
+        <p:nvSpPr>
+          <p:cNvPr id="4" name="Text Placeholder 3"/>
+          <p:cNvSpPr>
+            <a:spLocks noGrp="1"/>
+          </p:cNvSpPr>
+          <p:nvPr>
+            <p:ph type="body" idx="19" sz="quarter"/>
           </p:nvPr>
         </p:nvSpPr>
         <p:spPr/>
         <p:txBody>
           <a:bodyPr/>
           <a:lstStyle/>
-          <a:p>
-            <a:r>
-              <a:t>Vergaberecht — Schwellenwerte und Verfahren</a:t>
-            </a:r>
-          </a:p>
-        </p:txBody>
-      </p:sp>
-      <p:sp>
-        <p:nvSpPr>
-          <p:cNvPr id="5" name="Text Placeholder 4"/>
-          <p:cNvSpPr>
-            <a:spLocks noGrp="1"/>
-          </p:cNvSpPr>
-          <p:nvPr>
-            <p:ph type="body" idx="15" sz="quarter"/>
-          </p:nvPr>
-        </p:nvSpPr>
-        <p:spPr/>
-        <p:txBody>
-          <a:bodyPr/>
-          <a:lstStyle/>
-          <a:p>
-            <a:r>
-              <a:t>EU-Schwellenwerte seit 01.01.2026</a:t>
-            </a:r>
-          </a:p>
+          <a:p/>
         </p:txBody>
       </p:sp>
     </p:spTree>
@@ -20215,7 +20374,7 @@
             <a:spLocks noGrp="1"/>
           </p:cNvSpPr>
           <p:nvPr>
-            <p:ph idx="14" sz="quarter"/>
+            <p:ph idx="16" sz="quarter"/>
           </p:nvPr>
         </p:nvSpPr>
         <p:spPr/>
@@ -20223,213 +20382,327 @@
           <a:bodyPr/>
           <a:lstStyle/>
           <a:p>
+            <a:r>
+              <a:rPr sz="1300" b="1">
+                <a:solidFill>
+                  <a:srgbClr val="007B3E"/>
+                </a:solidFill>
+                <a:latin typeface="AOK Bundesweit"/>
+              </a:rPr>
+              <a:t>EU-Schwellenwerte (netto)</a:t>
+            </a:r>
+          </a:p>
+          <a:p>
             <a:pPr>
               <a:spcAft>
-                <a:spcPts val="600"/>
+                <a:spcPts val="400"/>
               </a:spcAft>
             </a:pPr>
             <a:r>
-              <a:rPr sz="1300" b="1">
-                <a:solidFill>
-                  <a:srgbClr val="007B3E"/>
+              <a:rPr sz="1100" b="1">
+                <a:solidFill>
+                  <a:srgbClr val="333333"/>
                 </a:solidFill>
                 <a:latin typeface="AOK Bundesweit"/>
               </a:rPr>
-              <a:t>Produktneutrale Ausschreibung:</a:t>
-            </a:r>
-            <a:r>
-              <a:rPr sz="1300" b="0">
+              <a:t>Bundesbehörden:</a:t>
+            </a:r>
+            <a:r>
+              <a:rPr sz="1100" b="0">
                 <a:solidFill>
                   <a:srgbClr val="333333"/>
                 </a:solidFill>
                 <a:latin typeface="AOK Bundesweit"/>
               </a:rPr>
-              <a:t> Funktionale Anforderungen definieren, kein Produkt vorschreiben (§ 31 Abs. 6 VgV)</a:t>
+              <a:t> 140.000 €</a:t>
             </a:r>
           </a:p>
           <a:p>
             <a:pPr>
               <a:spcAft>
-                <a:spcPts val="600"/>
+                <a:spcPts val="400"/>
               </a:spcAft>
             </a:pPr>
             <a:r>
-              <a:rPr sz="1300" b="1">
-                <a:solidFill>
-                  <a:srgbClr val="007B3E"/>
+              <a:rPr sz="1100" b="1">
+                <a:solidFill>
+                  <a:srgbClr val="333333"/>
                 </a:solidFill>
                 <a:latin typeface="AOK Bundesweit"/>
               </a:rPr>
-              <a:t>Losaufteilung:</a:t>
-            </a:r>
-            <a:r>
-              <a:rPr sz="1300" b="0">
+              <a:t>Sonstige öffentl. AG:</a:t>
+            </a:r>
+            <a:r>
+              <a:rPr sz="1100" b="0">
                 <a:solidFill>
                   <a:srgbClr val="333333"/>
                 </a:solidFill>
                 <a:latin typeface="AOK Bundesweit"/>
               </a:rPr>
-              <a:t> Hardware, Software, Dienstleistungen ggf. in separate Lose (§ 97 Abs. 4 GWB)</a:t>
+              <a:t> 216.000 €</a:t>
             </a:r>
           </a:p>
           <a:p>
             <a:pPr>
               <a:spcAft>
-                <a:spcPts val="600"/>
+                <a:spcPts val="400"/>
               </a:spcAft>
             </a:pPr>
+            <a:r>
+              <a:rPr sz="1100" b="1">
+                <a:solidFill>
+                  <a:srgbClr val="333333"/>
+                </a:solidFill>
+                <a:latin typeface="AOK Bundesweit"/>
+              </a:rPr>
+              <a:t>Sektorenauftraggeber:</a:t>
+            </a:r>
+            <a:r>
+              <a:rPr sz="1100" b="0">
+                <a:solidFill>
+                  <a:srgbClr val="333333"/>
+                </a:solidFill>
+                <a:latin typeface="AOK Bundesweit"/>
+              </a:rPr>
+              <a:t> 432.000 €</a:t>
+            </a:r>
           </a:p>
           <a:p>
             <a:pPr>
               <a:spcAft>
-                <a:spcPts val="600"/>
+                <a:spcPts val="400"/>
               </a:spcAft>
             </a:pPr>
-            <a:r>
-              <a:rPr sz="1300" b="1">
-                <a:solidFill>
-                  <a:srgbClr val="007B3E"/>
+          </a:p>
+          <a:p>
+            <a:pPr>
+              <a:spcAft>
+                <a:spcPts val="400"/>
+              </a:spcAft>
+            </a:pPr>
+            <a:r>
+              <a:rPr sz="1100" b="1">
+                <a:solidFill>
+                  <a:srgbClr val="333333"/>
                 </a:solidFill>
                 <a:latin typeface="AOK Bundesweit"/>
               </a:rPr>
-              <a:t>Empfohlene Zuschlagskriterien:</a:t>
+              <a:t>Unterschwellenbereich (UVgO):</a:t>
             </a:r>
           </a:p>
           <a:p>
             <a:pPr>
               <a:spcAft>
-                <a:spcPts val="600"/>
+                <a:spcPts val="400"/>
               </a:spcAft>
             </a:pPr>
             <a:r>
-              <a:rPr sz="1300" b="1">
-                <a:solidFill>
-                  <a:srgbClr val="007B3E"/>
+              <a:rPr sz="1100" b="1">
+                <a:solidFill>
+                  <a:srgbClr val="333333"/>
                 </a:solidFill>
                 <a:latin typeface="AOK Bundesweit"/>
               </a:rPr>
-              <a:t>  Preis:</a:t>
-            </a:r>
-            <a:r>
-              <a:rPr sz="1300" b="0">
+              <a:t>Direktvergabe:</a:t>
+            </a:r>
+            <a:r>
+              <a:rPr sz="1100" b="0">
                 <a:solidFill>
                   <a:srgbClr val="333333"/>
                 </a:solidFill>
                 <a:latin typeface="AOK Bundesweit"/>
               </a:rPr>
-              <a:t> 30–40 %</a:t>
+              <a:t> bis 100.000 € möglich</a:t>
             </a:r>
           </a:p>
           <a:p>
             <a:pPr>
               <a:spcAft>
-                <a:spcPts val="600"/>
+                <a:spcPts val="400"/>
               </a:spcAft>
             </a:pPr>
-            <a:r>
-              <a:rPr sz="1300" b="1">
-                <a:solidFill>
-                  <a:srgbClr val="007B3E"/>
+          </a:p>
+          <a:p>
+            <a:pPr>
+              <a:spcAft>
+                <a:spcPts val="400"/>
+              </a:spcAft>
+            </a:pPr>
+            <a:r>
+              <a:rPr sz="1100" b="1">
+                <a:solidFill>
+                  <a:srgbClr val="333333"/>
                 </a:solidFill>
                 <a:latin typeface="AOK Bundesweit"/>
               </a:rPr>
-              <a:t>  Technische Leistungsfähigkeit:</a:t>
-            </a:r>
-            <a:r>
-              <a:rPr sz="1300" b="0">
+              <a:t>Praxis:</a:t>
+            </a:r>
+            <a:r>
+              <a:rPr sz="1100" b="0">
                 <a:solidFill>
                   <a:srgbClr val="333333"/>
                 </a:solidFill>
                 <a:latin typeface="AOK Bundesweit"/>
               </a:rPr>
-              <a:t> 20–30 %</a:t>
+              <a:t> Bei 7.000 Desktops (TCO 10-34 Mio. €) ist eine EU-weite Ausschreibung zwingend erforderlich</a:t>
+            </a:r>
+          </a:p>
+        </p:txBody>
+      </p:sp>
+      <p:sp>
+        <p:nvSpPr>
+          <p:cNvPr id="3" name="Content Placeholder 2"/>
+          <p:cNvSpPr>
+            <a:spLocks noGrp="1"/>
+          </p:cNvSpPr>
+          <p:nvPr>
+            <p:ph idx="17" sz="quarter"/>
+          </p:nvPr>
+        </p:nvSpPr>
+        <p:spPr/>
+        <p:txBody>
+          <a:bodyPr/>
+          <a:lstStyle/>
+          <a:p>
+            <a:r>
+              <a:rPr sz="1300" b="1">
+                <a:solidFill>
+                  <a:srgbClr val="007B3E"/>
+                </a:solidFill>
+                <a:latin typeface="AOK Bundesweit"/>
+              </a:rPr>
+              <a:t>EVB-IT Vertragstypen</a:t>
             </a:r>
           </a:p>
           <a:p>
             <a:pPr>
               <a:spcAft>
-                <a:spcPts val="600"/>
+                <a:spcPts val="400"/>
               </a:spcAft>
             </a:pPr>
             <a:r>
-              <a:rPr sz="1300" b="1">
-                <a:solidFill>
-                  <a:srgbClr val="007B3E"/>
+              <a:rPr sz="1000" b="0">
+                <a:solidFill>
+                  <a:srgbClr val="333333"/>
                 </a:solidFill>
                 <a:latin typeface="AOK Bundesweit"/>
               </a:rPr>
-              <a:t>  Datenschutz / IT-Sicherheit:</a:t>
-            </a:r>
-            <a:r>
-              <a:rPr sz="1300" b="0">
+              <a:t>EVB-IT System — On-Premises VDI + Hardware</a:t>
+            </a:r>
+          </a:p>
+          <a:p>
+            <a:pPr>
+              <a:spcAft>
+                <a:spcPts val="400"/>
+              </a:spcAft>
+            </a:pPr>
+            <a:r>
+              <a:rPr sz="1000" b="0">
                 <a:solidFill>
                   <a:srgbClr val="333333"/>
                 </a:solidFill>
                 <a:latin typeface="AOK Bundesweit"/>
               </a:rPr>
-              <a:t> 15–25 %</a:t>
+              <a:t>EVB-IT Cloud — Cloud-VDI (AVD, Azure Local); C5-Testat erforderlich</a:t>
             </a:r>
           </a:p>
           <a:p>
             <a:pPr>
               <a:spcAft>
-                <a:spcPts val="600"/>
+                <a:spcPts val="400"/>
               </a:spcAft>
             </a:pPr>
             <a:r>
-              <a:rPr sz="1300" b="1">
-                <a:solidFill>
-                  <a:srgbClr val="007B3E"/>
+              <a:rPr sz="1000" b="0">
+                <a:solidFill>
+                  <a:srgbClr val="333333"/>
                 </a:solidFill>
                 <a:latin typeface="AOK Bundesweit"/>
               </a:rPr>
-              <a:t>  Support und SLA:</a:t>
-            </a:r>
-            <a:r>
-              <a:rPr sz="1300" b="0">
+              <a:t>EVB-IT Überlassung Typ B — Softwarelizenzen (z.B. UDS Enterprise)</a:t>
+            </a:r>
+          </a:p>
+          <a:p>
+            <a:pPr>
+              <a:spcAft>
+                <a:spcPts val="400"/>
+              </a:spcAft>
+            </a:pPr>
+            <a:r>
+              <a:rPr sz="1000" b="0">
                 <a:solidFill>
                   <a:srgbClr val="333333"/>
                 </a:solidFill>
                 <a:latin typeface="AOK Bundesweit"/>
               </a:rPr>
-              <a:t> 10–15 %</a:t>
+              <a:t>EVB-IT Pflege S — Wartung und Patching</a:t>
             </a:r>
           </a:p>
           <a:p>
             <a:pPr>
               <a:spcAft>
-                <a:spcPts val="600"/>
+                <a:spcPts val="400"/>
               </a:spcAft>
             </a:pPr>
             <a:r>
-              <a:rPr sz="1300" b="1">
-                <a:solidFill>
-                  <a:srgbClr val="007B3E"/>
+              <a:rPr sz="1000" b="0">
+                <a:solidFill>
+                  <a:srgbClr val="333333"/>
                 </a:solidFill>
                 <a:latin typeface="AOK Bundesweit"/>
               </a:rPr>
-              <a:t>  Migrationsfähigkeit / Exit-Strategie:</a:t>
-            </a:r>
-            <a:r>
-              <a:rPr sz="1300" b="0">
+              <a:t>EVB-IT Dienstvertrag — Implementierung/Beratung</a:t>
+            </a:r>
+          </a:p>
+          <a:p>
+            <a:pPr>
+              <a:spcAft>
+                <a:spcPts val="400"/>
+              </a:spcAft>
+            </a:pPr>
+            <a:r>
+              <a:rPr sz="1000" b="0">
                 <a:solidFill>
                   <a:srgbClr val="333333"/>
                 </a:solidFill>
                 <a:latin typeface="AOK Bundesweit"/>
               </a:rPr>
-              <a:t> 5–10 %</a:t>
-            </a:r>
-          </a:p>
-        </p:txBody>
-      </p:sp>
-      <p:sp>
-        <p:nvSpPr>
-          <p:cNvPr id="3" name="Text Placeholder 2"/>
-          <p:cNvSpPr>
-            <a:spLocks noGrp="1"/>
-          </p:cNvSpPr>
-          <p:nvPr>
-            <p:ph type="body" idx="15" sz="quarter"/>
+              <a:t>EVB-IT Rahmenvereinbarung — Modulare VDI-Leistungen</a:t>
+            </a:r>
+          </a:p>
+          <a:p>
+            <a:pPr>
+              <a:spcAft>
+                <a:spcPts val="400"/>
+              </a:spcAft>
+            </a:pPr>
+          </a:p>
+          <a:p>
+            <a:pPr>
+              <a:spcAft>
+                <a:spcPts val="400"/>
+              </a:spcAft>
+            </a:pPr>
+            <a:r>
+              <a:rPr sz="1000" b="1">
+                <a:solidFill>
+                  <a:srgbClr val="C00000"/>
+                </a:solidFill>
+                <a:latin typeface="AOK Bundesweit"/>
+              </a:rPr>
+              <a:t>Pflicht: EVB-IT für Bundesbehörden (§ 55 BHO)</a:t>
+            </a:r>
+          </a:p>
+        </p:txBody>
+      </p:sp>
+      <p:sp>
+        <p:nvSpPr>
+          <p:cNvPr id="4" name="Title 3"/>
+          <p:cNvSpPr>
+            <a:spLocks noGrp="1"/>
+          </p:cNvSpPr>
+          <p:nvPr>
+            <p:ph type="title"/>
           </p:nvPr>
         </p:nvSpPr>
         <p:spPr/>
@@ -20438,19 +20711,19 @@
           <a:lstStyle/>
           <a:p>
             <a:r>
-              <a:t>Empfohlene Zuschlagskriterien und produktneutrale Vergabe</a:t>
-            </a:r>
-          </a:p>
-        </p:txBody>
-      </p:sp>
-      <p:sp>
-        <p:nvSpPr>
-          <p:cNvPr id="4" name="Title 3"/>
-          <p:cNvSpPr>
-            <a:spLocks noGrp="1"/>
-          </p:cNvSpPr>
-          <p:nvPr>
-            <p:ph type="title"/>
+              <a:t>Vergaberecht — Schwellenwerte und Verfahren</a:t>
+            </a:r>
+          </a:p>
+        </p:txBody>
+      </p:sp>
+      <p:sp>
+        <p:nvSpPr>
+          <p:cNvPr id="5" name="Text Placeholder 4"/>
+          <p:cNvSpPr>
+            <a:spLocks noGrp="1"/>
+          </p:cNvSpPr>
+          <p:nvPr>
+            <p:ph type="body" idx="15" sz="quarter"/>
           </p:nvPr>
         </p:nvSpPr>
         <p:spPr/>
@@ -20459,7 +20732,7 @@
           <a:lstStyle/>
           <a:p>
             <a:r>
-              <a:t>Ausschreibungshinweise</a:t>
+              <a:t>EU-Schwellenwerte seit 01.01.2026</a:t>
             </a:r>
           </a:p>
         </p:txBody>
@@ -20484,12 +20757,12 @@
       <p:grpSpPr/>
       <p:sp>
         <p:nvSpPr>
-          <p:cNvPr id="2" name="Text Placeholder 1"/>
-          <p:cNvSpPr>
-            <a:spLocks noGrp="1"/>
-          </p:cNvSpPr>
-          <p:nvPr>
-            <p:ph type="body" idx="11" sz="quarter"/>
+          <p:cNvPr id="2" name="Content Placeholder 1"/>
+          <p:cNvSpPr>
+            <a:spLocks noGrp="1"/>
+          </p:cNvSpPr>
+          <p:nvPr>
+            <p:ph idx="14" sz="quarter"/>
           </p:nvPr>
         </p:nvSpPr>
         <p:spPr/>
@@ -20497,20 +20770,213 @@
           <a:bodyPr/>
           <a:lstStyle/>
           <a:p>
-            <a:r>
-              <a:t>Gewichtete Bewertungsmatrix</a:t>
-            </a:r>
-          </a:p>
-        </p:txBody>
-      </p:sp>
-      <p:sp>
-        <p:nvSpPr>
-          <p:cNvPr id="3" name="Title 2"/>
-          <p:cNvSpPr>
-            <a:spLocks noGrp="1"/>
-          </p:cNvSpPr>
-          <p:nvPr>
-            <p:ph type="title"/>
+            <a:pPr>
+              <a:spcAft>
+                <a:spcPts val="600"/>
+              </a:spcAft>
+            </a:pPr>
+            <a:r>
+              <a:rPr sz="1300" b="1">
+                <a:solidFill>
+                  <a:srgbClr val="007B3E"/>
+                </a:solidFill>
+                <a:latin typeface="AOK Bundesweit"/>
+              </a:rPr>
+              <a:t>Produktneutrale Ausschreibung:</a:t>
+            </a:r>
+            <a:r>
+              <a:rPr sz="1300" b="0">
+                <a:solidFill>
+                  <a:srgbClr val="333333"/>
+                </a:solidFill>
+                <a:latin typeface="AOK Bundesweit"/>
+              </a:rPr>
+              <a:t> Funktionale Anforderungen definieren, kein Produkt vorschreiben (§ 31 Abs. 6 VgV)</a:t>
+            </a:r>
+          </a:p>
+          <a:p>
+            <a:pPr>
+              <a:spcAft>
+                <a:spcPts val="600"/>
+              </a:spcAft>
+            </a:pPr>
+            <a:r>
+              <a:rPr sz="1300" b="1">
+                <a:solidFill>
+                  <a:srgbClr val="007B3E"/>
+                </a:solidFill>
+                <a:latin typeface="AOK Bundesweit"/>
+              </a:rPr>
+              <a:t>Losaufteilung:</a:t>
+            </a:r>
+            <a:r>
+              <a:rPr sz="1300" b="0">
+                <a:solidFill>
+                  <a:srgbClr val="333333"/>
+                </a:solidFill>
+                <a:latin typeface="AOK Bundesweit"/>
+              </a:rPr>
+              <a:t> Hardware, Software, Dienstleistungen ggf. in separate Lose (§ 97 Abs. 4 GWB)</a:t>
+            </a:r>
+          </a:p>
+          <a:p>
+            <a:pPr>
+              <a:spcAft>
+                <a:spcPts val="600"/>
+              </a:spcAft>
+            </a:pPr>
+          </a:p>
+          <a:p>
+            <a:pPr>
+              <a:spcAft>
+                <a:spcPts val="600"/>
+              </a:spcAft>
+            </a:pPr>
+            <a:r>
+              <a:rPr sz="1300" b="1">
+                <a:solidFill>
+                  <a:srgbClr val="007B3E"/>
+                </a:solidFill>
+                <a:latin typeface="AOK Bundesweit"/>
+              </a:rPr>
+              <a:t>Empfohlene Zuschlagskriterien:</a:t>
+            </a:r>
+          </a:p>
+          <a:p>
+            <a:pPr>
+              <a:spcAft>
+                <a:spcPts val="600"/>
+              </a:spcAft>
+            </a:pPr>
+            <a:r>
+              <a:rPr sz="1300" b="1">
+                <a:solidFill>
+                  <a:srgbClr val="007B3E"/>
+                </a:solidFill>
+                <a:latin typeface="AOK Bundesweit"/>
+              </a:rPr>
+              <a:t>  Preis:</a:t>
+            </a:r>
+            <a:r>
+              <a:rPr sz="1300" b="0">
+                <a:solidFill>
+                  <a:srgbClr val="333333"/>
+                </a:solidFill>
+                <a:latin typeface="AOK Bundesweit"/>
+              </a:rPr>
+              <a:t> 30–40 %</a:t>
+            </a:r>
+          </a:p>
+          <a:p>
+            <a:pPr>
+              <a:spcAft>
+                <a:spcPts val="600"/>
+              </a:spcAft>
+            </a:pPr>
+            <a:r>
+              <a:rPr sz="1300" b="1">
+                <a:solidFill>
+                  <a:srgbClr val="007B3E"/>
+                </a:solidFill>
+                <a:latin typeface="AOK Bundesweit"/>
+              </a:rPr>
+              <a:t>  Technische Leistungsfähigkeit:</a:t>
+            </a:r>
+            <a:r>
+              <a:rPr sz="1300" b="0">
+                <a:solidFill>
+                  <a:srgbClr val="333333"/>
+                </a:solidFill>
+                <a:latin typeface="AOK Bundesweit"/>
+              </a:rPr>
+              <a:t> 20–30 %</a:t>
+            </a:r>
+          </a:p>
+          <a:p>
+            <a:pPr>
+              <a:spcAft>
+                <a:spcPts val="600"/>
+              </a:spcAft>
+            </a:pPr>
+            <a:r>
+              <a:rPr sz="1300" b="1">
+                <a:solidFill>
+                  <a:srgbClr val="007B3E"/>
+                </a:solidFill>
+                <a:latin typeface="AOK Bundesweit"/>
+              </a:rPr>
+              <a:t>  Datenschutz / IT-Sicherheit:</a:t>
+            </a:r>
+            <a:r>
+              <a:rPr sz="1300" b="0">
+                <a:solidFill>
+                  <a:srgbClr val="333333"/>
+                </a:solidFill>
+                <a:latin typeface="AOK Bundesweit"/>
+              </a:rPr>
+              <a:t> 15–25 %</a:t>
+            </a:r>
+          </a:p>
+          <a:p>
+            <a:pPr>
+              <a:spcAft>
+                <a:spcPts val="600"/>
+              </a:spcAft>
+            </a:pPr>
+            <a:r>
+              <a:rPr sz="1300" b="1">
+                <a:solidFill>
+                  <a:srgbClr val="007B3E"/>
+                </a:solidFill>
+                <a:latin typeface="AOK Bundesweit"/>
+              </a:rPr>
+              <a:t>  Support und SLA:</a:t>
+            </a:r>
+            <a:r>
+              <a:rPr sz="1300" b="0">
+                <a:solidFill>
+                  <a:srgbClr val="333333"/>
+                </a:solidFill>
+                <a:latin typeface="AOK Bundesweit"/>
+              </a:rPr>
+              <a:t> 10–15 %</a:t>
+            </a:r>
+          </a:p>
+          <a:p>
+            <a:pPr>
+              <a:spcAft>
+                <a:spcPts val="600"/>
+              </a:spcAft>
+            </a:pPr>
+            <a:r>
+              <a:rPr sz="1300" b="1">
+                <a:solidFill>
+                  <a:srgbClr val="007B3E"/>
+                </a:solidFill>
+                <a:latin typeface="AOK Bundesweit"/>
+              </a:rPr>
+              <a:t>  Migrationsfähigkeit / Exit-Strategie:</a:t>
+            </a:r>
+            <a:r>
+              <a:rPr sz="1300" b="0">
+                <a:solidFill>
+                  <a:srgbClr val="333333"/>
+                </a:solidFill>
+                <a:latin typeface="AOK Bundesweit"/>
+              </a:rPr>
+              <a:t> 5–10 %</a:t>
+            </a:r>
+          </a:p>
+        </p:txBody>
+      </p:sp>
+      <p:sp>
+        <p:nvSpPr>
+          <p:cNvPr id="3" name="Text Placeholder 2"/>
+          <p:cNvSpPr>
+            <a:spLocks noGrp="1"/>
+          </p:cNvSpPr>
+          <p:nvPr>
+            <p:ph type="body" idx="15" sz="quarter"/>
           </p:nvPr>
         </p:nvSpPr>
         <p:spPr/>
@@ -20519,31 +20985,30 @@
           <a:lstStyle/>
           <a:p>
             <a:r>
-              <a:t>Bewertung und</a:t>
-            </a:r>
-          </a:p>
-          <a:p>
-            <a:r>
-              <a:t>Empfehlung</a:t>
-            </a:r>
-          </a:p>
-        </p:txBody>
-      </p:sp>
-      <p:sp>
-        <p:nvSpPr>
-          <p:cNvPr id="4" name="Text Placeholder 3"/>
-          <p:cNvSpPr>
-            <a:spLocks noGrp="1"/>
-          </p:cNvSpPr>
-          <p:nvPr>
-            <p:ph type="body" idx="19" sz="quarter"/>
+              <a:t>Empfohlene Zuschlagskriterien und produktneutrale Vergabe</a:t>
+            </a:r>
+          </a:p>
+        </p:txBody>
+      </p:sp>
+      <p:sp>
+        <p:nvSpPr>
+          <p:cNvPr id="4" name="Title 3"/>
+          <p:cNvSpPr>
+            <a:spLocks noGrp="1"/>
+          </p:cNvSpPr>
+          <p:nvPr>
+            <p:ph type="title"/>
           </p:nvPr>
         </p:nvSpPr>
         <p:spPr/>
         <p:txBody>
           <a:bodyPr/>
           <a:lstStyle/>
-          <a:p/>
+          <a:p>
+            <a:r>
+              <a:t>Ausschreibungshinweise</a:t>
+            </a:r>
+          </a:p>
         </p:txBody>
       </p:sp>
     </p:spTree>
@@ -20555,6 +21020,88 @@
 </file>
 
 <file path=ppt/slides/slide22.xml><?xml version="1.0" encoding="utf-8"?>
+<p:sld xmlns:a="http://schemas.openxmlformats.org/drawingml/2006/main" xmlns:p="http://schemas.openxmlformats.org/presentationml/2006/main" xmlns:r="http://schemas.openxmlformats.org/officeDocument/2006/relationships">
+  <p:cSld>
+    <p:spTree>
+      <p:nvGrpSpPr>
+        <p:cNvPr id="1" name=""/>
+        <p:cNvGrpSpPr/>
+        <p:nvPr/>
+      </p:nvGrpSpPr>
+      <p:grpSpPr/>
+      <p:sp>
+        <p:nvSpPr>
+          <p:cNvPr id="2" name="Text Placeholder 1"/>
+          <p:cNvSpPr>
+            <a:spLocks noGrp="1"/>
+          </p:cNvSpPr>
+          <p:nvPr>
+            <p:ph type="body" idx="11" sz="quarter"/>
+          </p:nvPr>
+        </p:nvSpPr>
+        <p:spPr/>
+        <p:txBody>
+          <a:bodyPr/>
+          <a:lstStyle/>
+          <a:p>
+            <a:r>
+              <a:t>Gewichtete Bewertungsmatrix</a:t>
+            </a:r>
+          </a:p>
+        </p:txBody>
+      </p:sp>
+      <p:sp>
+        <p:nvSpPr>
+          <p:cNvPr id="3" name="Title 2"/>
+          <p:cNvSpPr>
+            <a:spLocks noGrp="1"/>
+          </p:cNvSpPr>
+          <p:nvPr>
+            <p:ph type="title"/>
+          </p:nvPr>
+        </p:nvSpPr>
+        <p:spPr/>
+        <p:txBody>
+          <a:bodyPr/>
+          <a:lstStyle/>
+          <a:p>
+            <a:r>
+              <a:t>Bewertung und</a:t>
+            </a:r>
+          </a:p>
+          <a:p>
+            <a:r>
+              <a:t>Empfehlung</a:t>
+            </a:r>
+          </a:p>
+        </p:txBody>
+      </p:sp>
+      <p:sp>
+        <p:nvSpPr>
+          <p:cNvPr id="4" name="Text Placeholder 3"/>
+          <p:cNvSpPr>
+            <a:spLocks noGrp="1"/>
+          </p:cNvSpPr>
+          <p:nvPr>
+            <p:ph type="body" idx="19" sz="quarter"/>
+          </p:nvPr>
+        </p:nvSpPr>
+        <p:spPr/>
+        <p:txBody>
+          <a:bodyPr/>
+          <a:lstStyle/>
+          <a:p/>
+        </p:txBody>
+      </p:sp>
+    </p:spTree>
+  </p:cSld>
+  <p:clrMapOvr>
+    <a:masterClrMapping/>
+  </p:clrMapOvr>
+</p:sld>
+</file>
+
+<file path=ppt/slides/slide23.xml><?xml version="1.0" encoding="utf-8"?>
 <p:sld xmlns:a="http://schemas.openxmlformats.org/drawingml/2006/main" xmlns:p="http://schemas.openxmlformats.org/presentationml/2006/main" xmlns:r="http://schemas.openxmlformats.org/officeDocument/2006/relationships">
   <p:cSld>
     <p:spTree>
@@ -22117,286 +22664,6 @@
 </p:sld>
 </file>
 
-<file path=ppt/slides/slide23.xml><?xml version="1.0" encoding="utf-8"?>
-<p:sld xmlns:a="http://schemas.openxmlformats.org/drawingml/2006/main" xmlns:p="http://schemas.openxmlformats.org/presentationml/2006/main" xmlns:r="http://schemas.openxmlformats.org/officeDocument/2006/relationships">
-  <p:cSld>
-    <p:spTree>
-      <p:nvGrpSpPr>
-        <p:cNvPr id="1" name=""/>
-        <p:cNvGrpSpPr/>
-        <p:nvPr/>
-      </p:nvGrpSpPr>
-      <p:grpSpPr/>
-      <p:sp>
-        <p:nvSpPr>
-          <p:cNvPr id="2" name="Content Placeholder 1"/>
-          <p:cNvSpPr>
-            <a:spLocks noGrp="1"/>
-          </p:cNvSpPr>
-          <p:nvPr>
-            <p:ph idx="14" sz="quarter"/>
-          </p:nvPr>
-        </p:nvSpPr>
-        <p:spPr/>
-        <p:txBody>
-          <a:bodyPr/>
-          <a:lstStyle/>
-          <a:p>
-            <a:pPr>
-              <a:spcAft>
-                <a:spcPts val="800"/>
-              </a:spcAft>
-            </a:pPr>
-            <a:r>
-              <a:rPr sz="1400" b="1">
-                <a:solidFill>
-                  <a:srgbClr val="007B3E"/>
-                </a:solidFill>
-                <a:latin typeface="AOK Bundesweit"/>
-              </a:rPr>
-              <a:t>1. </a:t>
-            </a:r>
-            <a:r>
-              <a:rPr sz="1400" b="1">
-                <a:solidFill>
-                  <a:srgbClr val="333333"/>
-                </a:solidFill>
-                <a:latin typeface="AOK Bundesweit"/>
-              </a:rPr>
-              <a:t>Proxmox + UDS Enterprise (7,70)  </a:t>
-            </a:r>
-            <a:r>
-              <a:rPr sz="1200" b="0">
-                <a:solidFill>
-                  <a:srgbClr val="666666"/>
-                </a:solidFill>
-                <a:latin typeface="AOK Bundesweit"/>
-              </a:rPr>
-              <a:t>— Bestes Gesamtpaket: Kosten, Datenschutz, Skalierbarkeit — TCO ~15,5 Mio. €</a:t>
-            </a:r>
-          </a:p>
-          <a:p>
-            <a:pPr>
-              <a:spcAft>
-                <a:spcPts val="800"/>
-              </a:spcAft>
-            </a:pPr>
-            <a:r>
-              <a:rPr sz="1400" b="1">
-                <a:solidFill>
-                  <a:srgbClr val="007B3E"/>
-                </a:solidFill>
-                <a:latin typeface="AOK Bundesweit"/>
-              </a:rPr>
-              <a:t>2. </a:t>
-            </a:r>
-            <a:r>
-              <a:rPr sz="1400" b="1">
-                <a:solidFill>
-                  <a:srgbClr val="333333"/>
-                </a:solidFill>
-                <a:latin typeface="AOK Bundesweit"/>
-              </a:rPr>
-              <a:t>Windows RDS (7,25)  </a:t>
-            </a:r>
-            <a:r>
-              <a:rPr sz="1200" b="0">
-                <a:solidFill>
-                  <a:srgbClr val="666666"/>
-                </a:solidFill>
-                <a:latin typeface="AOK Bundesweit"/>
-              </a:rPr>
-              <a:t>— Günstigste Lösung (~9,8 Mio. €), aber sitzungsbasiert — keine echte VDI</a:t>
-            </a:r>
-          </a:p>
-          <a:p>
-            <a:pPr>
-              <a:spcAft>
-                <a:spcPts val="800"/>
-              </a:spcAft>
-            </a:pPr>
-            <a:r>
-              <a:rPr sz="1400" b="1">
-                <a:solidFill>
-                  <a:srgbClr val="E07C00"/>
-                </a:solidFill>
-                <a:latin typeface="AOK Bundesweit"/>
-              </a:rPr>
-              <a:t>3. </a:t>
-            </a:r>
-            <a:r>
-              <a:rPr sz="1400" b="1">
-                <a:solidFill>
-                  <a:srgbClr val="333333"/>
-                </a:solidFill>
-                <a:latin typeface="AOK Bundesweit"/>
-              </a:rPr>
-              <a:t>OpenDesktop (6,75)  </a:t>
-            </a:r>
-            <a:r>
-              <a:rPr sz="1200" b="0">
-                <a:solidFill>
-                  <a:srgbClr val="666666"/>
-                </a:solidFill>
-                <a:latin typeface="AOK Bundesweit"/>
-              </a:rPr>
-              <a:t>— Maximale Datensouveränität, aber ~10 FTE Personalaufwand</a:t>
-            </a:r>
-          </a:p>
-          <a:p>
-            <a:pPr>
-              <a:spcAft>
-                <a:spcPts val="800"/>
-              </a:spcAft>
-            </a:pPr>
-            <a:r>
-              <a:rPr sz="1400" b="1">
-                <a:solidFill>
-                  <a:srgbClr val="E07C00"/>
-                </a:solidFill>
-                <a:latin typeface="AOK Bundesweit"/>
-              </a:rPr>
-              <a:t>4. </a:t>
-            </a:r>
-            <a:r>
-              <a:rPr sz="1400" b="1">
-                <a:solidFill>
-                  <a:srgbClr val="333333"/>
-                </a:solidFill>
-                <a:latin typeface="AOK Bundesweit"/>
-              </a:rPr>
-              <a:t>Azure Local (6,30)  </a:t>
-            </a:r>
-            <a:r>
-              <a:rPr sz="1200" b="0">
-                <a:solidFill>
-                  <a:srgbClr val="666666"/>
-                </a:solidFill>
-                <a:latin typeface="AOK Bundesweit"/>
-              </a:rPr>
-              <a:t>— Guter Kompromiss, aber ~28,5 Mio. € und starker MS-Lock-in</a:t>
-            </a:r>
-          </a:p>
-          <a:p>
-            <a:pPr>
-              <a:spcAft>
-                <a:spcPts val="800"/>
-              </a:spcAft>
-            </a:pPr>
-            <a:r>
-              <a:rPr sz="1400" b="1">
-                <a:solidFill>
-                  <a:srgbClr val="C00000"/>
-                </a:solidFill>
-                <a:latin typeface="AOK Bundesweit"/>
-              </a:rPr>
-              <a:t>5. </a:t>
-            </a:r>
-            <a:r>
-              <a:rPr sz="1400" b="1">
-                <a:solidFill>
-                  <a:srgbClr val="333333"/>
-                </a:solidFill>
-                <a:latin typeface="AOK Bundesweit"/>
-              </a:rPr>
-              <a:t>Azure Virtual Desktop (5,90)  </a:t>
-            </a:r>
-            <a:r>
-              <a:rPr sz="1200" b="0">
-                <a:solidFill>
-                  <a:srgbClr val="666666"/>
-                </a:solidFill>
-                <a:latin typeface="AOK Bundesweit"/>
-              </a:rPr>
-              <a:t>— Autoscaling-Vorteil bei 7.000 Usern, Datenschutz kritisch</a:t>
-            </a:r>
-          </a:p>
-          <a:p>
-            <a:pPr>
-              <a:spcAft>
-                <a:spcPts val="800"/>
-              </a:spcAft>
-            </a:pPr>
-            <a:r>
-              <a:rPr sz="1400" b="1">
-                <a:solidFill>
-                  <a:srgbClr val="C00000"/>
-                </a:solidFill>
-                <a:latin typeface="AOK Bundesweit"/>
-              </a:rPr>
-              <a:t>6. </a:t>
-            </a:r>
-            <a:r>
-              <a:rPr sz="1400" b="1">
-                <a:solidFill>
-                  <a:srgbClr val="333333"/>
-                </a:solidFill>
-                <a:latin typeface="AOK Bundesweit"/>
-              </a:rPr>
-              <a:t>Omnissa Horizon (5,40)  </a:t>
-            </a:r>
-            <a:r>
-              <a:rPr sz="1200" b="0">
-                <a:solidFill>
-                  <a:srgbClr val="666666"/>
-                </a:solidFill>
-                <a:latin typeface="AOK Bundesweit"/>
-              </a:rPr>
-              <a:t>— Technisch ausgereift, aber teuerste Option (~34 Mio. €)</a:t>
-            </a:r>
-          </a:p>
-        </p:txBody>
-      </p:sp>
-      <p:sp>
-        <p:nvSpPr>
-          <p:cNvPr id="3" name="Text Placeholder 2"/>
-          <p:cNvSpPr>
-            <a:spLocks noGrp="1"/>
-          </p:cNvSpPr>
-          <p:nvPr>
-            <p:ph type="body" idx="15" sz="quarter"/>
-          </p:nvPr>
-        </p:nvSpPr>
-        <p:spPr/>
-        <p:txBody>
-          <a:bodyPr/>
-          <a:lstStyle/>
-          <a:p>
-            <a:r>
-              <a:t>Ergebnis der gewichteten Bewertung</a:t>
-            </a:r>
-          </a:p>
-        </p:txBody>
-      </p:sp>
-      <p:sp>
-        <p:nvSpPr>
-          <p:cNvPr id="4" name="Title 3"/>
-          <p:cNvSpPr>
-            <a:spLocks noGrp="1"/>
-          </p:cNvSpPr>
-          <p:nvPr>
-            <p:ph type="title"/>
-          </p:nvPr>
-        </p:nvSpPr>
-        <p:spPr/>
-        <p:txBody>
-          <a:bodyPr/>
-          <a:lstStyle/>
-          <a:p>
-            <a:r>
-              <a:t>Rangfolge und Handlungsempfehlung</a:t>
-            </a:r>
-          </a:p>
-        </p:txBody>
-      </p:sp>
-    </p:spTree>
-  </p:cSld>
-  <p:clrMapOvr>
-    <a:masterClrMapping/>
-  </p:clrMapOvr>
-</p:sld>
-</file>
-
 <file path=ppt/slides/slide24.xml><?xml version="1.0" encoding="utf-8"?>
 <p:sld xmlns:a="http://schemas.openxmlformats.org/drawingml/2006/main" xmlns:p="http://schemas.openxmlformats.org/presentationml/2006/main" xmlns:r="http://schemas.openxmlformats.org/officeDocument/2006/relationships">
   <p:cSld>
@@ -22423,11 +22690,8 @@
           <a:lstStyle/>
           <a:p>
             <a:pPr>
-              <a:spcBef>
+              <a:spcAft>
                 <a:spcPts val="800"/>
-              </a:spcBef>
-              <a:spcAft>
-                <a:spcPts val="400"/>
               </a:spcAft>
             </a:pPr>
             <a:r>
@@ -22437,7 +22701,25 @@
                 </a:solidFill>
                 <a:latin typeface="AOK Bundesweit"/>
               </a:rPr>
-              <a:t>Kurzfristig / einfache Anforderungen:</a:t>
+              <a:t>1. </a:t>
+            </a:r>
+            <a:r>
+              <a:rPr sz="1400" b="1">
+                <a:solidFill>
+                  <a:srgbClr val="333333"/>
+                </a:solidFill>
+                <a:latin typeface="AOK Bundesweit"/>
+              </a:rPr>
+              <a:t>Proxmox + UDS Enterprise (7,70)  </a:t>
+            </a:r>
+            <a:r>
+              <a:rPr sz="1200" b="0">
+                <a:solidFill>
+                  <a:srgbClr val="666666"/>
+                </a:solidFill>
+                <a:latin typeface="AOK Bundesweit"/>
+              </a:rPr>
+              <a:t>— Bestes Gesamtpaket: Kosten, Datenschutz, Skalierbarkeit — TCO ~15,5 Mio. €</a:t>
             </a:r>
           </a:p>
           <a:p>
@@ -22447,32 +22729,31 @@
               </a:spcAft>
             </a:pPr>
             <a:r>
-              <a:rPr sz="1300" b="0">
-                <a:solidFill>
-                  <a:srgbClr val="333333"/>
+              <a:rPr sz="1400" b="1">
+                <a:solidFill>
+                  <a:srgbClr val="007B3E"/>
                 </a:solidFill>
                 <a:latin typeface="AOK Bundesweit"/>
               </a:rPr>
-              <a:t>Windows RDS als bewährte Lösung — TCO ~9,8 Mio. € für 7.000 User, aber keine echte VDI und begrenzte Skalierungsfähigkeit (~100 RDS-Hosts nötig)</a:t>
-            </a:r>
-          </a:p>
-          <a:p>
-            <a:pPr>
-              <a:spcBef>
-                <a:spcPts val="800"/>
-              </a:spcBef>
-              <a:spcAft>
-                <a:spcPts val="400"/>
-              </a:spcAft>
-            </a:pPr>
+              <a:t>2. </a:t>
+            </a:r>
             <a:r>
               <a:rPr sz="1400" b="1">
                 <a:solidFill>
-                  <a:srgbClr val="007B3E"/>
+                  <a:srgbClr val="333333"/>
                 </a:solidFill>
                 <a:latin typeface="AOK Bundesweit"/>
               </a:rPr>
-              <a:t>Empfehlung für 7.000 Desktops:</a:t>
+              <a:t>Windows RDS (7,25)  </a:t>
+            </a:r>
+            <a:r>
+              <a:rPr sz="1200" b="0">
+                <a:solidFill>
+                  <a:srgbClr val="666666"/>
+                </a:solidFill>
+                <a:latin typeface="AOK Bundesweit"/>
+              </a:rPr>
+              <a:t>— Günstigste Lösung (~9,8 Mio. €), aber sitzungsbasiert — keine echte VDI</a:t>
             </a:r>
           </a:p>
           <a:p>
@@ -22482,32 +22763,31 @@
               </a:spcAft>
             </a:pPr>
             <a:r>
-              <a:rPr sz="1300" b="0">
-                <a:solidFill>
-                  <a:srgbClr val="333333"/>
+              <a:rPr sz="1400" b="1">
+                <a:solidFill>
+                  <a:srgbClr val="E07C00"/>
                 </a:solidFill>
                 <a:latin typeface="AOK Bundesweit"/>
               </a:rPr>
-              <a:t>Proxmox VE + UDS Enterprise — TCO ~15,5 Mio. €, echte VDI, datenschutzkonform, EU-Hersteller; bei dieser Größenordnung der beste Kosten-Nutzen-Kompromiss</a:t>
-            </a:r>
-          </a:p>
-          <a:p>
-            <a:pPr>
-              <a:spcBef>
-                <a:spcPts val="800"/>
-              </a:spcBef>
-              <a:spcAft>
-                <a:spcPts val="400"/>
-              </a:spcAft>
-            </a:pPr>
+              <a:t>3. </a:t>
+            </a:r>
             <a:r>
               <a:rPr sz="1400" b="1">
                 <a:solidFill>
-                  <a:srgbClr val="007B3E"/>
+                  <a:srgbClr val="333333"/>
                 </a:solidFill>
                 <a:latin typeface="AOK Bundesweit"/>
               </a:rPr>
-              <a:t>Strategisch / Digitale Souveränität:</a:t>
+              <a:t>OpenDesktop (6,75)  </a:t>
+            </a:r>
+            <a:r>
+              <a:rPr sz="1200" b="0">
+                <a:solidFill>
+                  <a:srgbClr val="666666"/>
+                </a:solidFill>
+                <a:latin typeface="AOK Bundesweit"/>
+              </a:rPr>
+              <a:t>— Maximale Datensouveränität, aber ~10 FTE Personalaufwand</a:t>
             </a:r>
           </a:p>
           <a:p>
@@ -22517,32 +22797,31 @@
               </a:spcAft>
             </a:pPr>
             <a:r>
-              <a:rPr sz="1300" b="0">
-                <a:solidFill>
-                  <a:srgbClr val="333333"/>
+              <a:rPr sz="1400" b="1">
+                <a:solidFill>
+                  <a:srgbClr val="E07C00"/>
                 </a:solidFill>
                 <a:latin typeface="AOK Bundesweit"/>
               </a:rPr>
-              <a:t>OpenDesktop-Ansatz als langfristige Open-Source-Strategie (~16,5 Mio. €), aber ~10 FTE nötig — nur mit entsprechendem Personalaufbau realistisch</a:t>
-            </a:r>
-          </a:p>
-          <a:p>
-            <a:pPr>
-              <a:spcBef>
-                <a:spcPts val="800"/>
-              </a:spcBef>
-              <a:spcAft>
-                <a:spcPts val="400"/>
-              </a:spcAft>
-            </a:pPr>
+              <a:t>4. </a:t>
+            </a:r>
             <a:r>
               <a:rPr sz="1400" b="1">
                 <a:solidFill>
-                  <a:srgbClr val="E07C00"/>
+                  <a:srgbClr val="333333"/>
                 </a:solidFill>
                 <a:latin typeface="AOK Bundesweit"/>
               </a:rPr>
-              <a:t>Mit Vorsicht:</a:t>
+              <a:t>Azure Local (6,30)  </a:t>
+            </a:r>
+            <a:r>
+              <a:rPr sz="1200" b="0">
+                <a:solidFill>
+                  <a:srgbClr val="666666"/>
+                </a:solidFill>
+                <a:latin typeface="AOK Bundesweit"/>
+              </a:rPr>
+              <a:t>— Guter Kompromiss, aber ~28,5 Mio. € und starker MS-Lock-in</a:t>
             </a:r>
           </a:p>
           <a:p>
@@ -22552,13 +22831,65 @@
               </a:spcAft>
             </a:pPr>
             <a:r>
-              <a:rPr sz="1300" b="0">
-                <a:solidFill>
-                  <a:srgbClr val="333333"/>
+              <a:rPr sz="1400" b="1">
+                <a:solidFill>
+                  <a:srgbClr val="C00000"/>
                 </a:solidFill>
                 <a:latin typeface="AOK Bundesweit"/>
               </a:rPr>
-              <a:t>Omnissa Horizon (~34 Mio. €) und AVD Cloud (~29,8 Mio. €) — erhebliches Kostenrisiko bei 7.000 Desktops; AVD zusätzlich Datenschutzrisiko (CLOUD Act)</a:t>
+              <a:t>5. </a:t>
+            </a:r>
+            <a:r>
+              <a:rPr sz="1400" b="1">
+                <a:solidFill>
+                  <a:srgbClr val="333333"/>
+                </a:solidFill>
+                <a:latin typeface="AOK Bundesweit"/>
+              </a:rPr>
+              <a:t>Azure Virtual Desktop (5,90)  </a:t>
+            </a:r>
+            <a:r>
+              <a:rPr sz="1200" b="0">
+                <a:solidFill>
+                  <a:srgbClr val="666666"/>
+                </a:solidFill>
+                <a:latin typeface="AOK Bundesweit"/>
+              </a:rPr>
+              <a:t>— Autoscaling-Vorteil bei 7.000 Usern, Datenschutz kritisch</a:t>
+            </a:r>
+          </a:p>
+          <a:p>
+            <a:pPr>
+              <a:spcAft>
+                <a:spcPts val="800"/>
+              </a:spcAft>
+            </a:pPr>
+            <a:r>
+              <a:rPr sz="1400" b="1">
+                <a:solidFill>
+                  <a:srgbClr val="C00000"/>
+                </a:solidFill>
+                <a:latin typeface="AOK Bundesweit"/>
+              </a:rPr>
+              <a:t>6. </a:t>
+            </a:r>
+            <a:r>
+              <a:rPr sz="1400" b="1">
+                <a:solidFill>
+                  <a:srgbClr val="333333"/>
+                </a:solidFill>
+                <a:latin typeface="AOK Bundesweit"/>
+              </a:rPr>
+              <a:t>Omnissa Horizon (5,40)  </a:t>
+            </a:r>
+            <a:r>
+              <a:rPr sz="1200" b="0">
+                <a:solidFill>
+                  <a:srgbClr val="666666"/>
+                </a:solidFill>
+                <a:latin typeface="AOK Bundesweit"/>
+              </a:rPr>
+              <a:t>— Technisch ausgereift, aber teuerste Option (~34 Mio. €)</a:t>
             </a:r>
           </a:p>
         </p:txBody>
@@ -22579,7 +22910,7 @@
           <a:lstStyle/>
           <a:p>
             <a:r>
-              <a:t>Strategische Empfehlung für die VDI-Einführung</a:t>
+              <a:t>Ergebnis der gewichteten Bewertung</a:t>
             </a:r>
           </a:p>
         </p:txBody>
@@ -22600,7 +22931,7 @@
           <a:lstStyle/>
           <a:p>
             <a:r>
-              <a:t>Handlungsempfehlung</a:t>
+              <a:t>Rangfolge und Handlungsempfehlung</a:t>
             </a:r>
           </a:p>
         </p:txBody>
@@ -22639,8 +22970,11 @@
           <a:lstStyle/>
           <a:p>
             <a:pPr>
+              <a:spcBef>
+                <a:spcPts val="800"/>
+              </a:spcBef>
               <a:spcAft>
-                <a:spcPts val="200"/>
+                <a:spcPts val="400"/>
               </a:spcAft>
             </a:pPr>
             <a:r>
@@ -22650,7 +22984,7 @@
                 </a:solidFill>
                 <a:latin typeface="AOK Bundesweit"/>
               </a:rPr>
-              <a:t>1.  Anforderungsanalyse</a:t>
+              <a:t>Kurzfristig / einfache Anforderungen:</a:t>
             </a:r>
           </a:p>
           <a:p>
@@ -22660,15 +22994,196 @@
               </a:spcAft>
             </a:pPr>
             <a:r>
-              <a:rPr sz="1200" b="0">
-                <a:solidFill>
-                  <a:srgbClr val="666666"/>
+              <a:rPr sz="1300" b="0">
+                <a:solidFill>
+                  <a:srgbClr val="333333"/>
                 </a:solidFill>
                 <a:latin typeface="AOK Bundesweit"/>
               </a:rPr>
-              <a:t>     7.000 Desktops: Nutzerprofile, Anwendungslandschaft, Performance-Klassen definieren</a:t>
-            </a:r>
-          </a:p>
+              <a:t>Windows RDS als bewährte Lösung — TCO ~9,8 Mio. € für 7.000 User, aber keine echte VDI und begrenzte Skalierungsfähigkeit (~100 RDS-Hosts nötig)</a:t>
+            </a:r>
+          </a:p>
+          <a:p>
+            <a:pPr>
+              <a:spcBef>
+                <a:spcPts val="800"/>
+              </a:spcBef>
+              <a:spcAft>
+                <a:spcPts val="400"/>
+              </a:spcAft>
+            </a:pPr>
+            <a:r>
+              <a:rPr sz="1400" b="1">
+                <a:solidFill>
+                  <a:srgbClr val="007B3E"/>
+                </a:solidFill>
+                <a:latin typeface="AOK Bundesweit"/>
+              </a:rPr>
+              <a:t>Empfehlung für 7.000 Desktops:</a:t>
+            </a:r>
+          </a:p>
+          <a:p>
+            <a:pPr>
+              <a:spcAft>
+                <a:spcPts val="800"/>
+              </a:spcAft>
+            </a:pPr>
+            <a:r>
+              <a:rPr sz="1300" b="0">
+                <a:solidFill>
+                  <a:srgbClr val="333333"/>
+                </a:solidFill>
+                <a:latin typeface="AOK Bundesweit"/>
+              </a:rPr>
+              <a:t>Proxmox VE + UDS Enterprise — TCO ~15,5 Mio. €, echte VDI, datenschutzkonform, EU-Hersteller; bei dieser Größenordnung der beste Kosten-Nutzen-Kompromiss</a:t>
+            </a:r>
+          </a:p>
+          <a:p>
+            <a:pPr>
+              <a:spcBef>
+                <a:spcPts val="800"/>
+              </a:spcBef>
+              <a:spcAft>
+                <a:spcPts val="400"/>
+              </a:spcAft>
+            </a:pPr>
+            <a:r>
+              <a:rPr sz="1400" b="1">
+                <a:solidFill>
+                  <a:srgbClr val="007B3E"/>
+                </a:solidFill>
+                <a:latin typeface="AOK Bundesweit"/>
+              </a:rPr>
+              <a:t>Strategisch / Digitale Souveränität:</a:t>
+            </a:r>
+          </a:p>
+          <a:p>
+            <a:pPr>
+              <a:spcAft>
+                <a:spcPts val="800"/>
+              </a:spcAft>
+            </a:pPr>
+            <a:r>
+              <a:rPr sz="1300" b="0">
+                <a:solidFill>
+                  <a:srgbClr val="333333"/>
+                </a:solidFill>
+                <a:latin typeface="AOK Bundesweit"/>
+              </a:rPr>
+              <a:t>OpenDesktop-Ansatz als langfristige Open-Source-Strategie (~16,5 Mio. €), aber ~10 FTE nötig — nur mit entsprechendem Personalaufbau realistisch</a:t>
+            </a:r>
+          </a:p>
+          <a:p>
+            <a:pPr>
+              <a:spcBef>
+                <a:spcPts val="800"/>
+              </a:spcBef>
+              <a:spcAft>
+                <a:spcPts val="400"/>
+              </a:spcAft>
+            </a:pPr>
+            <a:r>
+              <a:rPr sz="1400" b="1">
+                <a:solidFill>
+                  <a:srgbClr val="E07C00"/>
+                </a:solidFill>
+                <a:latin typeface="AOK Bundesweit"/>
+              </a:rPr>
+              <a:t>Mit Vorsicht:</a:t>
+            </a:r>
+          </a:p>
+          <a:p>
+            <a:pPr>
+              <a:spcAft>
+                <a:spcPts val="800"/>
+              </a:spcAft>
+            </a:pPr>
+            <a:r>
+              <a:rPr sz="1300" b="0">
+                <a:solidFill>
+                  <a:srgbClr val="333333"/>
+                </a:solidFill>
+                <a:latin typeface="AOK Bundesweit"/>
+              </a:rPr>
+              <a:t>Omnissa Horizon (~34 Mio. €) und AVD Cloud (~29,8 Mio. €) — erhebliches Kostenrisiko bei 7.000 Desktops; AVD zusätzlich Datenschutzrisiko (CLOUD Act)</a:t>
+            </a:r>
+          </a:p>
+        </p:txBody>
+      </p:sp>
+      <p:sp>
+        <p:nvSpPr>
+          <p:cNvPr id="3" name="Text Placeholder 2"/>
+          <p:cNvSpPr>
+            <a:spLocks noGrp="1"/>
+          </p:cNvSpPr>
+          <p:nvPr>
+            <p:ph type="body" idx="15" sz="quarter"/>
+          </p:nvPr>
+        </p:nvSpPr>
+        <p:spPr/>
+        <p:txBody>
+          <a:bodyPr/>
+          <a:lstStyle/>
+          <a:p>
+            <a:r>
+              <a:t>Strategische Empfehlung für die VDI-Einführung</a:t>
+            </a:r>
+          </a:p>
+        </p:txBody>
+      </p:sp>
+      <p:sp>
+        <p:nvSpPr>
+          <p:cNvPr id="4" name="Title 3"/>
+          <p:cNvSpPr>
+            <a:spLocks noGrp="1"/>
+          </p:cNvSpPr>
+          <p:nvPr>
+            <p:ph type="title"/>
+          </p:nvPr>
+        </p:nvSpPr>
+        <p:spPr/>
+        <p:txBody>
+          <a:bodyPr/>
+          <a:lstStyle/>
+          <a:p>
+            <a:r>
+              <a:t>Handlungsempfehlung</a:t>
+            </a:r>
+          </a:p>
+        </p:txBody>
+      </p:sp>
+    </p:spTree>
+  </p:cSld>
+  <p:clrMapOvr>
+    <a:masterClrMapping/>
+  </p:clrMapOvr>
+</p:sld>
+</file>
+
+<file path=ppt/slides/slide26.xml><?xml version="1.0" encoding="utf-8"?>
+<p:sld xmlns:a="http://schemas.openxmlformats.org/drawingml/2006/main" xmlns:p="http://schemas.openxmlformats.org/presentationml/2006/main" xmlns:r="http://schemas.openxmlformats.org/officeDocument/2006/relationships">
+  <p:cSld>
+    <p:spTree>
+      <p:nvGrpSpPr>
+        <p:cNvPr id="1" name=""/>
+        <p:cNvGrpSpPr/>
+        <p:nvPr/>
+      </p:nvGrpSpPr>
+      <p:grpSpPr/>
+      <p:sp>
+        <p:nvSpPr>
+          <p:cNvPr id="2" name="Content Placeholder 1"/>
+          <p:cNvSpPr>
+            <a:spLocks noGrp="1"/>
+          </p:cNvSpPr>
+          <p:nvPr>
+            <p:ph idx="14" sz="quarter"/>
+          </p:nvPr>
+        </p:nvSpPr>
+        <p:spPr/>
+        <p:txBody>
+          <a:bodyPr/>
+          <a:lstStyle/>
           <a:p>
             <a:pPr>
               <a:spcAft>
@@ -22682,7 +23197,7 @@
                 </a:solidFill>
                 <a:latin typeface="AOK Bundesweit"/>
               </a:rPr>
-              <a:t>2.  Datenschutz-Folgenabschätzung (DSFA)</a:t>
+              <a:t>1.  Anforderungsanalyse</a:t>
             </a:r>
           </a:p>
           <a:p>
@@ -22698,7 +23213,7 @@
                 </a:solidFill>
                 <a:latin typeface="AOK Bundesweit"/>
               </a:rPr>
-              <a:t>     Durchführung für favorisierte Lösungen</a:t>
+              <a:t>     7.000 Desktops: Nutzerprofile, Anwendungslandschaft, Performance-Klassen definieren</a:t>
             </a:r>
           </a:p>
           <a:p>
@@ -22714,7 +23229,7 @@
                 </a:solidFill>
                 <a:latin typeface="AOK Bundesweit"/>
               </a:rPr>
-              <a:t>3.  Proof of Concept (PoC)</a:t>
+              <a:t>2.  Benutzerprofilanalyse GPU</a:t>
             </a:r>
           </a:p>
           <a:p>
@@ -22730,7 +23245,7 @@
                 </a:solidFill>
                 <a:latin typeface="AOK Bundesweit"/>
               </a:rPr>
-              <a:t>     Pilotierung mit 2-3 favorisierten Lösungen</a:t>
+              <a:t>     Klären: Wie viele Nutzer benötigen GPU-Power? (CAD, GIS, PACS, Multimedia, KI)</a:t>
             </a:r>
           </a:p>
           <a:p>
@@ -22746,7 +23261,7 @@
                 </a:solidFill>
                 <a:latin typeface="AOK Bundesweit"/>
               </a:rPr>
-              <a:t>4.  Abstimmung mit dem DSB</a:t>
+              <a:t>3.  Test-/PoC-Hardware beschaffen</a:t>
             </a:r>
           </a:p>
           <a:p>
@@ -22762,7 +23277,7 @@
                 </a:solidFill>
                 <a:latin typeface="AOK Bundesweit"/>
               </a:rPr>
-              <a:t>     Datenschutzbeauftragten einbeziehen</a:t>
+              <a:t>     Dedizierte Hardware für Proof of Concept (ca. 65.000–190.000 €)</a:t>
             </a:r>
           </a:p>
           <a:p>
@@ -22778,7 +23293,7 @@
                 </a:solidFill>
                 <a:latin typeface="AOK Bundesweit"/>
               </a:rPr>
-              <a:t>5.  Marktrecherche (§ 28 VgV)</a:t>
+              <a:t>4.  Proof of Concept (PoC)</a:t>
             </a:r>
           </a:p>
           <a:p>
@@ -22794,7 +23309,7 @@
                 </a:solidFill>
                 <a:latin typeface="AOK Bundesweit"/>
               </a:rPr>
-              <a:t>     Markterkundung und Lieferantengespräche</a:t>
+              <a:t>     Pilotierung mit 2–3 favorisierten Lösungen</a:t>
             </a:r>
           </a:p>
           <a:p>
@@ -22810,7 +23325,7 @@
                 </a:solidFill>
                 <a:latin typeface="AOK Bundesweit"/>
               </a:rPr>
-              <a:t>6.  Vergabeunterlage erstellen</a:t>
+              <a:t>5.  Migrationsstrategie festlegen</a:t>
             </a:r>
           </a:p>
           <a:p>
@@ -22826,7 +23341,7 @@
                 </a:solidFill>
                 <a:latin typeface="AOK Bundesweit"/>
               </a:rPr>
-              <a:t>     Funktionale Leistungsbeschreibung</a:t>
+              <a:t>     Parallelbetrieb-Kapazität und Migrations-Hardware bestimmen</a:t>
             </a:r>
           </a:p>
           <a:p>
@@ -22842,7 +23357,7 @@
                 </a:solidFill>
                 <a:latin typeface="AOK Bundesweit"/>
               </a:rPr>
-              <a:t>7.  EU-weite Ausschreibung</a:t>
+              <a:t>6.  DSFA + Abstimmung mit DSB</a:t>
             </a:r>
           </a:p>
           <a:p>
@@ -22858,7 +23373,39 @@
                 </a:solidFill>
                 <a:latin typeface="AOK Bundesweit"/>
               </a:rPr>
-              <a:t>     Bei 7.000 Desktops zwingend erforderlich (TCO &gt;&gt; Schwellenwert)</a:t>
+              <a:t>     Datenschutz-Folgenabschätzung und Datenschutzbeauftragten einbeziehen</a:t>
+            </a:r>
+          </a:p>
+          <a:p>
+            <a:pPr>
+              <a:spcAft>
+                <a:spcPts val="200"/>
+              </a:spcAft>
+            </a:pPr>
+            <a:r>
+              <a:rPr sz="1400" b="1">
+                <a:solidFill>
+                  <a:srgbClr val="007B3E"/>
+                </a:solidFill>
+                <a:latin typeface="AOK Bundesweit"/>
+              </a:rPr>
+              <a:t>7.  Marktrecherche + EU-Ausschreibung</a:t>
+            </a:r>
+          </a:p>
+          <a:p>
+            <a:pPr>
+              <a:spcAft>
+                <a:spcPts val="800"/>
+              </a:spcAft>
+            </a:pPr>
+            <a:r>
+              <a:rPr sz="1200" b="0">
+                <a:solidFill>
+                  <a:srgbClr val="666666"/>
+                </a:solidFill>
+                <a:latin typeface="AOK Bundesweit"/>
+              </a:rPr>
+              <a:t>     Markterkundung (§ 28 VgV), dann EU-weite Vergabe (TCO &gt;&gt; Schwellenwert)</a:t>
             </a:r>
           </a:p>
         </p:txBody>

</xml_diff>

<commit_message>
Exkurs 7a (200% vs 120% Kapazität) in Präsentation eingebaut
Drei neue Folien: Trennfolie, Modellvergleichstabelle und
Kosten-/Risikobewertung mit Mitigationsmaßnahmen.
Agenda um den Exkurs-Punkt ergänzt.

https://claude.ai/code/session_015mHD4NfjMbda5YrGvujwfD
</commit_message>
<xml_diff>
--- a/docs/VDI-Vergleichsanalyse.pptx
+++ b/docs/VDI-Vergleichsanalyse.pptx
@@ -37,6 +37,9 @@
     <p:sldId id="279" r:id="rId40"/>
     <p:sldId id="280" r:id="rId41"/>
     <p:sldId id="281" r:id="rId42"/>
+    <p:sldId id="282" r:id="rId43"/>
+    <p:sldId id="283" r:id="rId44"/>
+    <p:sldId id="284" r:id="rId45"/>
   </p:sldIdLst>
   <p:sldSz cx="12192000" cy="6858000"/>
   <p:notesSz cx="6858000" cy="9144000"/>
@@ -14792,6 +14795,22 @@
           </a:p>
           <a:p>
             <a:pPr>
+              <a:spcAft>
+                <a:spcPts val="300"/>
+              </a:spcAft>
+            </a:pPr>
+            <a:r>
+              <a:rPr sz="1000" b="0">
+                <a:solidFill>
+                  <a:srgbClr val="333333"/>
+                </a:solidFill>
+                <a:latin typeface="AOK Bundesweit"/>
+              </a:rPr>
+              <a:t>+ Enterprise-Support über Fujitsu als bestehender Dienstleister verfügbar</a:t>
+            </a:r>
+          </a:p>
+          <a:p>
+            <a:pPr>
               <a:spcBef>
                 <a:spcPts val="1200"/>
               </a:spcBef>
@@ -20307,7 +20326,7 @@
                 </a:solidFill>
                 <a:latin typeface="AOK Bundesweit"/>
               </a:rPr>
-              <a:t>7.  Bewertungsmatrix und Empfehlung</a:t>
+              <a:t>7.  Exkurs: 200 % vs. 120 % Kapazität</a:t>
             </a:r>
           </a:p>
           <a:p>
@@ -20323,7 +20342,23 @@
                 </a:solidFill>
                 <a:latin typeface="AOK Bundesweit"/>
               </a:rPr>
-              <a:t>8.  Nächste Schritte</a:t>
+              <a:t>8.  Bewertungsmatrix und Empfehlung</a:t>
+            </a:r>
+          </a:p>
+          <a:p>
+            <a:pPr>
+              <a:spcAft>
+                <a:spcPts val="1000"/>
+              </a:spcAft>
+            </a:pPr>
+            <a:r>
+              <a:rPr sz="1800" b="0">
+                <a:solidFill>
+                  <a:srgbClr val="333333"/>
+                </a:solidFill>
+                <a:latin typeface="AOK Bundesweit"/>
+              </a:rPr>
+              <a:t>9.  Nächste Schritte</a:t>
             </a:r>
           </a:p>
         </p:txBody>
@@ -21045,7 +21080,7 @@
           <a:lstStyle/>
           <a:p>
             <a:r>
-              <a:t>Gewichtete Bewertungsmatrix</a:t>
+              <a:t>Brauchen wir wirklich die volle Verdopplung?</a:t>
             </a:r>
           </a:p>
         </p:txBody>
@@ -21066,12 +21101,12 @@
           <a:lstStyle/>
           <a:p>
             <a:r>
-              <a:t>Bewertung und</a:t>
-            </a:r>
-          </a:p>
-          <a:p>
-            <a:r>
-              <a:t>Empfehlung</a:t>
+              <a:t>Exkurs:</a:t>
+            </a:r>
+          </a:p>
+          <a:p>
+            <a:r>
+              <a:t>200 % vs. 120 %</a:t>
             </a:r>
           </a:p>
         </p:txBody>
@@ -21102,6 +21137,1050 @@
 </file>
 
 <file path=ppt/slides/slide23.xml><?xml version="1.0" encoding="utf-8"?>
+<p:sld xmlns:a="http://schemas.openxmlformats.org/drawingml/2006/main" xmlns:p="http://schemas.openxmlformats.org/presentationml/2006/main" xmlns:r="http://schemas.openxmlformats.org/officeDocument/2006/relationships">
+  <p:cSld>
+    <p:spTree>
+      <p:nvGrpSpPr>
+        <p:cNvPr id="1" name=""/>
+        <p:cNvGrpSpPr/>
+        <p:nvPr/>
+      </p:nvGrpSpPr>
+      <p:grpSpPr/>
+      <p:sp>
+        <p:nvSpPr>
+          <p:cNvPr id="2" name="Title 1"/>
+          <p:cNvSpPr>
+            <a:spLocks noGrp="1"/>
+          </p:cNvSpPr>
+          <p:nvPr>
+            <p:ph type="title"/>
+          </p:nvPr>
+        </p:nvSpPr>
+        <p:spPr/>
+        <p:txBody>
+          <a:bodyPr/>
+          <a:lstStyle/>
+          <a:p>
+            <a:r>
+              <a:t>200 % vs. 120 % — Kapazitätsmodelle im Vergleich</a:t>
+            </a:r>
+          </a:p>
+        </p:txBody>
+      </p:sp>
+      <p:sp>
+        <p:nvSpPr>
+          <p:cNvPr id="3" name="Text Placeholder 2"/>
+          <p:cNvSpPr>
+            <a:spLocks noGrp="1"/>
+          </p:cNvSpPr>
+          <p:nvPr>
+            <p:ph type="body" idx="15" sz="quarter"/>
+          </p:nvPr>
+        </p:nvSpPr>
+        <p:spPr/>
+        <p:txBody>
+          <a:bodyPr/>
+          <a:lstStyle/>
+          <a:p/>
+        </p:txBody>
+      </p:sp>
+      <p:graphicFrame>
+        <p:nvGraphicFramePr>
+          <p:cNvPr id="4" name="Table 3"/>
+          <p:cNvGraphicFramePr>
+            <a:graphicFrameLocks noGrp="1"/>
+          </p:cNvGraphicFramePr>
+          <p:nvPr/>
+        </p:nvGraphicFramePr>
+        <p:xfrm>
+          <a:off x="540000" y="1260000"/>
+          <a:ext cx="7920000" cy="4680000"/>
+        </p:xfrm>
+        <a:graphic>
+          <a:graphicData uri="http://schemas.openxmlformats.org/drawingml/2006/table">
+            <a:tbl>
+              <a:tblPr firstRow="1" bandRow="1">
+                <a:tableStyleId>{5C22544A-7EE6-4342-B048-85BDC9FD1C3A}</a:tableStyleId>
+              </a:tblPr>
+              <a:tblGrid>
+                <a:gridCol w="1980000"/>
+                <a:gridCol w="2970000"/>
+                <a:gridCol w="2970000"/>
+              </a:tblGrid>
+              <a:tr h="468000">
+                <a:tc>
+                  <a:txBody>
+                    <a:bodyPr wrap="square"/>
+                    <a:lstStyle/>
+                    <a:p>
+                      <a:pPr algn="ctr"/>
+                      <a:r>
+                        <a:rPr sz="1000" b="1">
+                          <a:solidFill>
+                            <a:srgbClr val="FFFFFF"/>
+                          </a:solidFill>
+                          <a:latin typeface="AOK Bundesweit"/>
+                        </a:rPr>
+                        <a:t>Kriterium</a:t>
+                      </a:r>
+                    </a:p>
+                  </a:txBody>
+                  <a:tcPr anchor="ctr">
+                    <a:solidFill>
+                      <a:srgbClr val="007B3E"/>
+                    </a:solidFill>
+                  </a:tcPr>
+                </a:tc>
+                <a:tc>
+                  <a:txBody>
+                    <a:bodyPr wrap="square"/>
+                    <a:lstStyle/>
+                    <a:p>
+                      <a:pPr algn="ctr"/>
+                      <a:r>
+                        <a:rPr sz="1000" b="1">
+                          <a:solidFill>
+                            <a:srgbClr val="FFFFFF"/>
+                          </a:solidFill>
+                          <a:latin typeface="AOK Bundesweit"/>
+                        </a:rPr>
+                        <a:t>200 % (Ist-Zustand)</a:t>
+                      </a:r>
+                    </a:p>
+                  </a:txBody>
+                  <a:tcPr anchor="ctr">
+                    <a:solidFill>
+                      <a:srgbClr val="007B3E"/>
+                    </a:solidFill>
+                  </a:tcPr>
+                </a:tc>
+                <a:tc>
+                  <a:txBody>
+                    <a:bodyPr wrap="square"/>
+                    <a:lstStyle/>
+                    <a:p>
+                      <a:pPr algn="ctr"/>
+                      <a:r>
+                        <a:rPr sz="1000" b="1">
+                          <a:solidFill>
+                            <a:srgbClr val="FFFFFF"/>
+                          </a:solidFill>
+                          <a:latin typeface="AOK Bundesweit"/>
+                        </a:rPr>
+                        <a:t>120 % (Alternative)</a:t>
+                      </a:r>
+                    </a:p>
+                  </a:txBody>
+                  <a:tcPr anchor="ctr">
+                    <a:solidFill>
+                      <a:srgbClr val="007B3E"/>
+                    </a:solidFill>
+                  </a:tcPr>
+                </a:tc>
+              </a:tr>
+              <a:tr h="468000">
+                <a:tc>
+                  <a:txBody>
+                    <a:bodyPr wrap="square"/>
+                    <a:lstStyle/>
+                    <a:p>
+                      <a:pPr algn="l"/>
+                      <a:r>
+                        <a:rPr sz="900" b="1">
+                          <a:solidFill>
+                            <a:srgbClr val="333333"/>
+                          </a:solidFill>
+                          <a:latin typeface="AOK Bundesweit"/>
+                        </a:rPr>
+                        <a:t>Infrastruktur-Faktor</a:t>
+                      </a:r>
+                    </a:p>
+                  </a:txBody>
+                  <a:tcPr anchor="ctr"/>
+                </a:tc>
+                <a:tc>
+                  <a:txBody>
+                    <a:bodyPr wrap="square"/>
+                    <a:lstStyle/>
+                    <a:p>
+                      <a:pPr algn="l"/>
+                      <a:r>
+                        <a:rPr sz="900" b="0">
+                          <a:solidFill>
+                            <a:srgbClr val="333333"/>
+                          </a:solidFill>
+                          <a:latin typeface="AOK Bundesweit"/>
+                        </a:rPr>
+                        <a:t>2,0× der Basiskapazität</a:t>
+                      </a:r>
+                    </a:p>
+                  </a:txBody>
+                  <a:tcPr anchor="ctr"/>
+                </a:tc>
+                <a:tc>
+                  <a:txBody>
+                    <a:bodyPr wrap="square"/>
+                    <a:lstStyle/>
+                    <a:p>
+                      <a:pPr algn="l"/>
+                      <a:r>
+                        <a:rPr sz="900" b="0">
+                          <a:solidFill>
+                            <a:srgbClr val="333333"/>
+                          </a:solidFill>
+                          <a:latin typeface="AOK Bundesweit"/>
+                        </a:rPr>
+                        <a:t>1,2× der Basiskapazität</a:t>
+                      </a:r>
+                    </a:p>
+                  </a:txBody>
+                  <a:tcPr anchor="ctr">
+                    <a:solidFill>
+                      <a:srgbClr val="F0F8F0"/>
+                    </a:solidFill>
+                  </a:tcPr>
+                </a:tc>
+              </a:tr>
+              <a:tr h="468000">
+                <a:tc>
+                  <a:txBody>
+                    <a:bodyPr wrap="square"/>
+                    <a:lstStyle/>
+                    <a:p>
+                      <a:pPr algn="l"/>
+                      <a:r>
+                        <a:rPr sz="900" b="1">
+                          <a:solidFill>
+                            <a:srgbClr val="333333"/>
+                          </a:solidFill>
+                          <a:latin typeface="AOK Bundesweit"/>
+                        </a:rPr>
+                        <a:t>Prinzip</a:t>
+                      </a:r>
+                    </a:p>
+                  </a:txBody>
+                  <a:tcPr anchor="ctr"/>
+                </a:tc>
+                <a:tc>
+                  <a:txBody>
+                    <a:bodyPr wrap="square"/>
+                    <a:lstStyle/>
+                    <a:p>
+                      <a:pPr algn="l"/>
+                      <a:r>
+                        <a:rPr sz="900" b="0">
+                          <a:solidFill>
+                            <a:srgbClr val="333333"/>
+                          </a:solidFill>
+                          <a:latin typeface="AOK Bundesweit"/>
+                        </a:rPr>
+                        <a:t>100 % pro RZ
+(Active-Passive)</a:t>
+                      </a:r>
+                    </a:p>
+                  </a:txBody>
+                  <a:tcPr anchor="ctr"/>
+                </a:tc>
+                <a:tc>
+                  <a:txBody>
+                    <a:bodyPr wrap="square"/>
+                    <a:lstStyle/>
+                    <a:p>
+                      <a:pPr algn="l"/>
+                      <a:r>
+                        <a:rPr sz="900" b="0">
+                          <a:solidFill>
+                            <a:srgbClr val="333333"/>
+                          </a:solidFill>
+                          <a:latin typeface="AOK Bundesweit"/>
+                        </a:rPr>
+                        <a:t>100 % Betrieb + 20 % Puffer
+(Active-Active)</a:t>
+                      </a:r>
+                    </a:p>
+                  </a:txBody>
+                  <a:tcPr anchor="ctr">
+                    <a:solidFill>
+                      <a:srgbClr val="F0F8F0"/>
+                    </a:solidFill>
+                  </a:tcPr>
+                </a:tc>
+              </a:tr>
+              <a:tr h="468000">
+                <a:tc>
+                  <a:txBody>
+                    <a:bodyPr wrap="square"/>
+                    <a:lstStyle/>
+                    <a:p>
+                      <a:pPr algn="l"/>
+                      <a:r>
+                        <a:rPr sz="900" b="1">
+                          <a:solidFill>
+                            <a:srgbClr val="333333"/>
+                          </a:solidFill>
+                          <a:latin typeface="AOK Bundesweit"/>
+                        </a:rPr>
+                        <a:t>Hardwarekosten</a:t>
+                      </a:r>
+                    </a:p>
+                  </a:txBody>
+                  <a:tcPr anchor="ctr"/>
+                </a:tc>
+                <a:tc>
+                  <a:txBody>
+                    <a:bodyPr wrap="square"/>
+                    <a:lstStyle/>
+                    <a:p>
+                      <a:pPr algn="l"/>
+                      <a:r>
+                        <a:rPr sz="900" b="0">
+                          <a:solidFill>
+                            <a:srgbClr val="333333"/>
+                          </a:solidFill>
+                          <a:latin typeface="AOK Bundesweit"/>
+                        </a:rPr>
+                        <a:t>2× Basis</a:t>
+                      </a:r>
+                    </a:p>
+                  </a:txBody>
+                  <a:tcPr anchor="ctr"/>
+                </a:tc>
+                <a:tc>
+                  <a:txBody>
+                    <a:bodyPr wrap="square"/>
+                    <a:lstStyle/>
+                    <a:p>
+                      <a:pPr algn="l"/>
+                      <a:r>
+                        <a:rPr sz="900" b="0">
+                          <a:solidFill>
+                            <a:srgbClr val="333333"/>
+                          </a:solidFill>
+                          <a:latin typeface="AOK Bundesweit"/>
+                        </a:rPr>
+                        <a:t>1,2× Basis</a:t>
+                      </a:r>
+                    </a:p>
+                  </a:txBody>
+                  <a:tcPr anchor="ctr">
+                    <a:solidFill>
+                      <a:srgbClr val="F0F8F0"/>
+                    </a:solidFill>
+                  </a:tcPr>
+                </a:tc>
+              </a:tr>
+              <a:tr h="468000">
+                <a:tc>
+                  <a:txBody>
+                    <a:bodyPr wrap="square"/>
+                    <a:lstStyle/>
+                    <a:p>
+                      <a:pPr algn="l"/>
+                      <a:r>
+                        <a:rPr sz="900" b="1">
+                          <a:solidFill>
+                            <a:srgbClr val="333333"/>
+                          </a:solidFill>
+                          <a:latin typeface="AOK Bundesweit"/>
+                        </a:rPr>
+                        <a:t>Lizenzkosten</a:t>
+                      </a:r>
+                    </a:p>
+                  </a:txBody>
+                  <a:tcPr anchor="ctr"/>
+                </a:tc>
+                <a:tc>
+                  <a:txBody>
+                    <a:bodyPr wrap="square"/>
+                    <a:lstStyle/>
+                    <a:p>
+                      <a:pPr algn="l"/>
+                      <a:r>
+                        <a:rPr sz="900" b="0">
+                          <a:solidFill>
+                            <a:srgbClr val="333333"/>
+                          </a:solidFill>
+                          <a:latin typeface="AOK Bundesweit"/>
+                        </a:rPr>
+                        <a:t>2× Basis</a:t>
+                      </a:r>
+                    </a:p>
+                  </a:txBody>
+                  <a:tcPr anchor="ctr"/>
+                </a:tc>
+                <a:tc>
+                  <a:txBody>
+                    <a:bodyPr wrap="square"/>
+                    <a:lstStyle/>
+                    <a:p>
+                      <a:pPr algn="l"/>
+                      <a:r>
+                        <a:rPr sz="900" b="0">
+                          <a:solidFill>
+                            <a:srgbClr val="333333"/>
+                          </a:solidFill>
+                          <a:latin typeface="AOK Bundesweit"/>
+                        </a:rPr>
+                        <a:t>1,2× Basis</a:t>
+                      </a:r>
+                    </a:p>
+                  </a:txBody>
+                  <a:tcPr anchor="ctr">
+                    <a:solidFill>
+                      <a:srgbClr val="F0F8F0"/>
+                    </a:solidFill>
+                  </a:tcPr>
+                </a:tc>
+              </a:tr>
+              <a:tr h="468000">
+                <a:tc>
+                  <a:txBody>
+                    <a:bodyPr wrap="square"/>
+                    <a:lstStyle/>
+                    <a:p>
+                      <a:pPr algn="l"/>
+                      <a:r>
+                        <a:rPr sz="900" b="1">
+                          <a:solidFill>
+                            <a:srgbClr val="333333"/>
+                          </a:solidFill>
+                          <a:latin typeface="AOK Bundesweit"/>
+                        </a:rPr>
+                        <a:t>Strom / RZ-Fläche</a:t>
+                      </a:r>
+                    </a:p>
+                  </a:txBody>
+                  <a:tcPr anchor="ctr"/>
+                </a:tc>
+                <a:tc>
+                  <a:txBody>
+                    <a:bodyPr wrap="square"/>
+                    <a:lstStyle/>
+                    <a:p>
+                      <a:pPr algn="l"/>
+                      <a:r>
+                        <a:rPr sz="900" b="0">
+                          <a:solidFill>
+                            <a:srgbClr val="333333"/>
+                          </a:solidFill>
+                          <a:latin typeface="AOK Bundesweit"/>
+                        </a:rPr>
+                        <a:t>2× Basis</a:t>
+                      </a:r>
+                    </a:p>
+                  </a:txBody>
+                  <a:tcPr anchor="ctr"/>
+                </a:tc>
+                <a:tc>
+                  <a:txBody>
+                    <a:bodyPr wrap="square"/>
+                    <a:lstStyle/>
+                    <a:p>
+                      <a:pPr algn="l"/>
+                      <a:r>
+                        <a:rPr sz="900" b="0">
+                          <a:solidFill>
+                            <a:srgbClr val="333333"/>
+                          </a:solidFill>
+                          <a:latin typeface="AOK Bundesweit"/>
+                        </a:rPr>
+                        <a:t>1,2× Basis</a:t>
+                      </a:r>
+                    </a:p>
+                  </a:txBody>
+                  <a:tcPr anchor="ctr">
+                    <a:solidFill>
+                      <a:srgbClr val="F0F8F0"/>
+                    </a:solidFill>
+                  </a:tcPr>
+                </a:tc>
+              </a:tr>
+              <a:tr h="468000">
+                <a:tc>
+                  <a:txBody>
+                    <a:bodyPr wrap="square"/>
+                    <a:lstStyle/>
+                    <a:p>
+                      <a:pPr algn="l"/>
+                      <a:r>
+                        <a:rPr sz="900" b="1">
+                          <a:solidFill>
+                            <a:srgbClr val="333333"/>
+                          </a:solidFill>
+                          <a:latin typeface="AOK Bundesweit"/>
+                        </a:rPr>
+                        <a:t>Verfügbarkeit bei
+RZ-Ausfall</a:t>
+                      </a:r>
+                    </a:p>
+                  </a:txBody>
+                  <a:tcPr anchor="ctr"/>
+                </a:tc>
+                <a:tc>
+                  <a:txBody>
+                    <a:bodyPr wrap="square"/>
+                    <a:lstStyle/>
+                    <a:p>
+                      <a:pPr algn="l"/>
+                      <a:r>
+                        <a:rPr sz="900" b="0">
+                          <a:solidFill>
+                            <a:srgbClr val="333333"/>
+                          </a:solidFill>
+                          <a:latin typeface="AOK Bundesweit"/>
+                        </a:rPr>
+                        <a:t>100 % — voller Betrieb
+ohne Einschränkung</a:t>
+                      </a:r>
+                    </a:p>
+                  </a:txBody>
+                  <a:tcPr anchor="ctr"/>
+                </a:tc>
+                <a:tc>
+                  <a:txBody>
+                    <a:bodyPr wrap="square"/>
+                    <a:lstStyle/>
+                    <a:p>
+                      <a:pPr algn="l"/>
+                      <a:r>
+                        <a:rPr sz="900" b="0">
+                          <a:solidFill>
+                            <a:srgbClr val="333333"/>
+                          </a:solidFill>
+                          <a:latin typeface="AOK Bundesweit"/>
+                        </a:rPr>
+                        <a:t>Eingeschränkt —
+Priorisierung nötig</a:t>
+                      </a:r>
+                    </a:p>
+                  </a:txBody>
+                  <a:tcPr anchor="ctr">
+                    <a:solidFill>
+                      <a:srgbClr val="F0F8F0"/>
+                    </a:solidFill>
+                  </a:tcPr>
+                </a:tc>
+              </a:tr>
+              <a:tr h="468000">
+                <a:tc>
+                  <a:txBody>
+                    <a:bodyPr wrap="square"/>
+                    <a:lstStyle/>
+                    <a:p>
+                      <a:pPr algn="l"/>
+                      <a:r>
+                        <a:rPr sz="900" b="1">
+                          <a:solidFill>
+                            <a:srgbClr val="333333"/>
+                          </a:solidFill>
+                          <a:latin typeface="AOK Bundesweit"/>
+                        </a:rPr>
+                        <a:t>Betankung /
+Provisioning</a:t>
+                      </a:r>
+                    </a:p>
+                  </a:txBody>
+                  <a:tcPr anchor="ctr"/>
+                </a:tc>
+                <a:tc>
+                  <a:txBody>
+                    <a:bodyPr wrap="square"/>
+                    <a:lstStyle/>
+                    <a:p>
+                      <a:pPr algn="l"/>
+                      <a:r>
+                        <a:rPr sz="900" b="0">
+                          <a:solidFill>
+                            <a:srgbClr val="333333"/>
+                          </a:solidFill>
+                          <a:latin typeface="AOK Bundesweit"/>
+                        </a:rPr>
+                        <a:t>Jederzeit volle Kapazität</a:t>
+                      </a:r>
+                    </a:p>
+                  </a:txBody>
+                  <a:tcPr anchor="ctr"/>
+                </a:tc>
+                <a:tc>
+                  <a:txBody>
+                    <a:bodyPr wrap="square"/>
+                    <a:lstStyle/>
+                    <a:p>
+                      <a:pPr algn="l"/>
+                      <a:r>
+                        <a:rPr sz="900" b="0">
+                          <a:solidFill>
+                            <a:srgbClr val="333333"/>
+                          </a:solidFill>
+                          <a:latin typeface="AOK Bundesweit"/>
+                        </a:rPr>
+                        <a:t>20 % Puffer deckt
+laufende Rollouts ab</a:t>
+                      </a:r>
+                    </a:p>
+                  </a:txBody>
+                  <a:tcPr anchor="ctr">
+                    <a:solidFill>
+                      <a:srgbClr val="F0F8F0"/>
+                    </a:solidFill>
+                  </a:tcPr>
+                </a:tc>
+              </a:tr>
+              <a:tr h="468000">
+                <a:tc>
+                  <a:txBody>
+                    <a:bodyPr wrap="square"/>
+                    <a:lstStyle/>
+                    <a:p>
+                      <a:pPr algn="l"/>
+                      <a:r>
+                        <a:rPr sz="900" b="1">
+                          <a:solidFill>
+                            <a:srgbClr val="333333"/>
+                          </a:solidFill>
+                          <a:latin typeface="AOK Bundesweit"/>
+                        </a:rPr>
+                        <a:t>Performance-Puffer</a:t>
+                      </a:r>
+                    </a:p>
+                  </a:txBody>
+                  <a:tcPr anchor="ctr"/>
+                </a:tc>
+                <a:tc>
+                  <a:txBody>
+                    <a:bodyPr wrap="square"/>
+                    <a:lstStyle/>
+                    <a:p>
+                      <a:pPr algn="l"/>
+                      <a:r>
+                        <a:rPr sz="900" b="0">
+                          <a:solidFill>
+                            <a:srgbClr val="333333"/>
+                          </a:solidFill>
+                          <a:latin typeface="AOK Bundesweit"/>
+                        </a:rPr>
+                        <a:t>Großzügig</a:t>
+                      </a:r>
+                    </a:p>
+                  </a:txBody>
+                  <a:tcPr anchor="ctr"/>
+                </a:tc>
+                <a:tc>
+                  <a:txBody>
+                    <a:bodyPr wrap="square"/>
+                    <a:lstStyle/>
+                    <a:p>
+                      <a:pPr algn="l"/>
+                      <a:r>
+                        <a:rPr sz="900" b="0">
+                          <a:solidFill>
+                            <a:srgbClr val="333333"/>
+                          </a:solidFill>
+                          <a:latin typeface="AOK Bundesweit"/>
+                        </a:rPr>
+                        <a:t>20 % Headroom —
+normale Lastspitzen</a:t>
+                      </a:r>
+                    </a:p>
+                  </a:txBody>
+                  <a:tcPr anchor="ctr">
+                    <a:solidFill>
+                      <a:srgbClr val="F0F8F0"/>
+                    </a:solidFill>
+                  </a:tcPr>
+                </a:tc>
+              </a:tr>
+              <a:tr h="468000">
+                <a:tc>
+                  <a:txBody>
+                    <a:bodyPr wrap="square"/>
+                    <a:lstStyle/>
+                    <a:p>
+                      <a:pPr algn="l"/>
+                      <a:r>
+                        <a:rPr sz="900" b="1">
+                          <a:solidFill>
+                            <a:srgbClr val="333333"/>
+                          </a:solidFill>
+                          <a:latin typeface="AOK Bundesweit"/>
+                        </a:rPr>
+                        <a:t>Kostenersparnis</a:t>
+                      </a:r>
+                    </a:p>
+                  </a:txBody>
+                  <a:tcPr anchor="ctr"/>
+                </a:tc>
+                <a:tc>
+                  <a:txBody>
+                    <a:bodyPr wrap="square"/>
+                    <a:lstStyle/>
+                    <a:p>
+                      <a:pPr algn="l"/>
+                      <a:r>
+                        <a:rPr sz="900" b="0">
+                          <a:solidFill>
+                            <a:srgbClr val="333333"/>
+                          </a:solidFill>
+                          <a:latin typeface="AOK Bundesweit"/>
+                        </a:rPr>
+                        <a:t>Referenz</a:t>
+                      </a:r>
+                    </a:p>
+                  </a:txBody>
+                  <a:tcPr anchor="ctr"/>
+                </a:tc>
+                <a:tc>
+                  <a:txBody>
+                    <a:bodyPr wrap="square"/>
+                    <a:lstStyle/>
+                    <a:p>
+                      <a:pPr algn="l"/>
+                      <a:r>
+                        <a:rPr sz="900" b="0">
+                          <a:solidFill>
+                            <a:srgbClr val="007B3E"/>
+                          </a:solidFill>
+                          <a:latin typeface="AOK Bundesweit"/>
+                        </a:rPr>
+                        <a:t>ca. 40 % weniger</a:t>
+                      </a:r>
+                    </a:p>
+                  </a:txBody>
+                  <a:tcPr anchor="ctr">
+                    <a:solidFill>
+                      <a:srgbClr val="F0F8F0"/>
+                    </a:solidFill>
+                  </a:tcPr>
+                </a:tc>
+              </a:tr>
+            </a:tbl>
+          </a:graphicData>
+        </a:graphic>
+      </p:graphicFrame>
+    </p:spTree>
+  </p:cSld>
+  <p:clrMapOvr>
+    <a:masterClrMapping/>
+  </p:clrMapOvr>
+</p:sld>
+</file>
+
+<file path=ppt/slides/slide24.xml><?xml version="1.0" encoding="utf-8"?>
+<p:sld xmlns:a="http://schemas.openxmlformats.org/drawingml/2006/main" xmlns:p="http://schemas.openxmlformats.org/presentationml/2006/main" xmlns:r="http://schemas.openxmlformats.org/officeDocument/2006/relationships">
+  <p:cSld>
+    <p:spTree>
+      <p:nvGrpSpPr>
+        <p:cNvPr id="1" name=""/>
+        <p:cNvGrpSpPr/>
+        <p:nvPr/>
+      </p:nvGrpSpPr>
+      <p:grpSpPr/>
+      <p:sp>
+        <p:nvSpPr>
+          <p:cNvPr id="2" name="Content Placeholder 1"/>
+          <p:cNvSpPr>
+            <a:spLocks noGrp="1"/>
+          </p:cNvSpPr>
+          <p:nvPr>
+            <p:ph idx="16" sz="quarter"/>
+          </p:nvPr>
+        </p:nvSpPr>
+        <p:spPr/>
+        <p:txBody>
+          <a:bodyPr/>
+          <a:lstStyle/>
+          <a:p/>
+          <a:p>
+            <a:pPr algn="l">
+              <a:spcBef>
+                <a:spcPts val="0"/>
+              </a:spcBef>
+              <a:spcAft>
+                <a:spcPts val="1000"/>
+              </a:spcAft>
+            </a:pPr>
+            <a:r>
+              <a:rPr sz="1300" b="1">
+                <a:solidFill>
+                  <a:srgbClr val="007B3E"/>
+                </a:solidFill>
+                <a:latin typeface="AOK Bundesweit"/>
+              </a:rPr>
+              <a:t>Risiko bei 120 % — Mitigation</a:t>
+            </a:r>
+          </a:p>
+          <a:p>
+            <a:pPr>
+              <a:spcAft>
+                <a:spcPts val="800"/>
+              </a:spcAft>
+            </a:pPr>
+            <a:r>
+              <a:rPr sz="1100" b="1">
+                <a:solidFill>
+                  <a:srgbClr val="333333"/>
+                </a:solidFill>
+                <a:latin typeface="AOK Bundesweit"/>
+              </a:rPr>
+              <a:t>Priorisierte Wiederherstellung:</a:t>
+            </a:r>
+            <a:r>
+              <a:rPr sz="1100" b="0">
+                <a:solidFill>
+                  <a:srgbClr val="333333"/>
+                </a:solidFill>
+                <a:latin typeface="AOK Bundesweit"/>
+              </a:rPr>
+              <a:t> Tier-1-Desktops (geschäftskritisch) zuerst, Tier-2 zeitversetzt</a:t>
+            </a:r>
+          </a:p>
+          <a:p>
+            <a:pPr>
+              <a:spcAft>
+                <a:spcPts val="800"/>
+              </a:spcAft>
+            </a:pPr>
+            <a:r>
+              <a:rPr sz="1100" b="1">
+                <a:solidFill>
+                  <a:srgbClr val="333333"/>
+                </a:solidFill>
+                <a:latin typeface="AOK Bundesweit"/>
+              </a:rPr>
+              <a:t>Elastische Skalierung:</a:t>
+            </a:r>
+            <a:r>
+              <a:rPr sz="1100" b="0">
+                <a:solidFill>
+                  <a:srgbClr val="333333"/>
+                </a:solidFill>
+                <a:latin typeface="AOK Bundesweit"/>
+              </a:rPr>
+              <a:t> Proxmox HA verteilt VMs in Minuten auf verbleibende Hosts</a:t>
+            </a:r>
+          </a:p>
+          <a:p>
+            <a:pPr>
+              <a:spcAft>
+                <a:spcPts val="800"/>
+              </a:spcAft>
+            </a:pPr>
+            <a:r>
+              <a:rPr sz="1100" b="1">
+                <a:solidFill>
+                  <a:srgbClr val="333333"/>
+                </a:solidFill>
+                <a:latin typeface="AOK Bundesweit"/>
+              </a:rPr>
+              <a:t>Degraded Mode:</a:t>
+            </a:r>
+            <a:r>
+              <a:rPr sz="1100" b="0">
+                <a:solidFill>
+                  <a:srgbClr val="333333"/>
+                </a:solidFill>
+                <a:latin typeface="AOK Bundesweit"/>
+              </a:rPr>
+              <a:t> Kurzzeitig reduzierte Ressourcen pro VM akzeptabel</a:t>
+            </a:r>
+          </a:p>
+          <a:p>
+            <a:pPr>
+              <a:spcAft>
+                <a:spcPts val="1200"/>
+              </a:spcAft>
+            </a:pPr>
+          </a:p>
+          <a:p>
+            <a:pPr algn="l">
+              <a:spcBef>
+                <a:spcPts val="0"/>
+              </a:spcBef>
+              <a:spcAft>
+                <a:spcPts val="600"/>
+              </a:spcAft>
+            </a:pPr>
+            <a:r>
+              <a:rPr sz="1300" b="1">
+                <a:solidFill>
+                  <a:srgbClr val="007B3E"/>
+                </a:solidFill>
+                <a:latin typeface="AOK Bundesweit"/>
+              </a:rPr>
+              <a:t>Empfehlung</a:t>
+            </a:r>
+          </a:p>
+          <a:p>
+            <a:pPr algn="l">
+              <a:spcBef>
+                <a:spcPts val="0"/>
+              </a:spcBef>
+              <a:spcAft>
+                <a:spcPts val="400"/>
+              </a:spcAft>
+            </a:pPr>
+            <a:r>
+              <a:rPr sz="1100" b="0">
+                <a:solidFill>
+                  <a:srgbClr val="333333"/>
+                </a:solidFill>
+                <a:latin typeface="AOK Bundesweit"/>
+              </a:rPr>
+              <a:t>Workshop mit RZ-Betrieb, IT-Sicherheit und Einkauf — SLA-Anforderungen definieren, reale Lastdaten analysieren, Kapazitätspuffer bestimmen.</a:t>
+            </a:r>
+          </a:p>
+        </p:txBody>
+      </p:sp>
+      <p:sp>
+        <p:nvSpPr>
+          <p:cNvPr id="3" name="Content Placeholder 2"/>
+          <p:cNvSpPr>
+            <a:spLocks noGrp="1"/>
+          </p:cNvSpPr>
+          <p:nvPr>
+            <p:ph idx="17" sz="quarter"/>
+          </p:nvPr>
+        </p:nvSpPr>
+        <p:spPr/>
+        <p:txBody>
+          <a:bodyPr/>
+          <a:lstStyle/>
+          <a:p/>
+        </p:txBody>
+      </p:sp>
+      <p:sp>
+        <p:nvSpPr>
+          <p:cNvPr id="4" name="Title 3"/>
+          <p:cNvSpPr>
+            <a:spLocks noGrp="1"/>
+          </p:cNvSpPr>
+          <p:nvPr>
+            <p:ph type="title"/>
+          </p:nvPr>
+        </p:nvSpPr>
+        <p:spPr/>
+        <p:txBody>
+          <a:bodyPr/>
+          <a:lstStyle/>
+          <a:p>
+            <a:r>
+              <a:t>200 % vs. 120 % — Kosten und Risikobewertung</a:t>
+            </a:r>
+          </a:p>
+        </p:txBody>
+      </p:sp>
+      <p:sp>
+        <p:nvSpPr>
+          <p:cNvPr id="5" name="Text Placeholder 4"/>
+          <p:cNvSpPr>
+            <a:spLocks noGrp="1"/>
+          </p:cNvSpPr>
+          <p:nvPr>
+            <p:ph type="body" idx="15" sz="quarter"/>
+          </p:nvPr>
+        </p:nvSpPr>
+        <p:spPr/>
+        <p:txBody>
+          <a:bodyPr/>
+          <a:lstStyle/>
+          <a:p>
+            <a:r>
+              <a:t>Rechenbeispiel und Mitigationsmaßnahmen</a:t>
+            </a:r>
+          </a:p>
+        </p:txBody>
+      </p:sp>
+    </p:spTree>
+  </p:cSld>
+  <p:clrMapOvr>
+    <a:masterClrMapping/>
+  </p:clrMapOvr>
+</p:sld>
+</file>
+
+<file path=ppt/slides/slide25.xml><?xml version="1.0" encoding="utf-8"?>
+<p:sld xmlns:a="http://schemas.openxmlformats.org/drawingml/2006/main" xmlns:p="http://schemas.openxmlformats.org/presentationml/2006/main" xmlns:r="http://schemas.openxmlformats.org/officeDocument/2006/relationships">
+  <p:cSld>
+    <p:spTree>
+      <p:nvGrpSpPr>
+        <p:cNvPr id="1" name=""/>
+        <p:cNvGrpSpPr/>
+        <p:nvPr/>
+      </p:nvGrpSpPr>
+      <p:grpSpPr/>
+      <p:sp>
+        <p:nvSpPr>
+          <p:cNvPr id="2" name="Text Placeholder 1"/>
+          <p:cNvSpPr>
+            <a:spLocks noGrp="1"/>
+          </p:cNvSpPr>
+          <p:nvPr>
+            <p:ph type="body" idx="11" sz="quarter"/>
+          </p:nvPr>
+        </p:nvSpPr>
+        <p:spPr/>
+        <p:txBody>
+          <a:bodyPr/>
+          <a:lstStyle/>
+          <a:p>
+            <a:r>
+              <a:t>Gewichtete Bewertungsmatrix</a:t>
+            </a:r>
+          </a:p>
+        </p:txBody>
+      </p:sp>
+      <p:sp>
+        <p:nvSpPr>
+          <p:cNvPr id="3" name="Title 2"/>
+          <p:cNvSpPr>
+            <a:spLocks noGrp="1"/>
+          </p:cNvSpPr>
+          <p:nvPr>
+            <p:ph type="title"/>
+          </p:nvPr>
+        </p:nvSpPr>
+        <p:spPr/>
+        <p:txBody>
+          <a:bodyPr/>
+          <a:lstStyle/>
+          <a:p>
+            <a:r>
+              <a:t>Bewertung und</a:t>
+            </a:r>
+          </a:p>
+          <a:p>
+            <a:r>
+              <a:t>Empfehlung</a:t>
+            </a:r>
+          </a:p>
+        </p:txBody>
+      </p:sp>
+      <p:sp>
+        <p:nvSpPr>
+          <p:cNvPr id="4" name="Text Placeholder 3"/>
+          <p:cNvSpPr>
+            <a:spLocks noGrp="1"/>
+          </p:cNvSpPr>
+          <p:nvPr>
+            <p:ph type="body" idx="19" sz="quarter"/>
+          </p:nvPr>
+        </p:nvSpPr>
+        <p:spPr/>
+        <p:txBody>
+          <a:bodyPr/>
+          <a:lstStyle/>
+          <a:p/>
+        </p:txBody>
+      </p:sp>
+    </p:spTree>
+  </p:cSld>
+  <p:clrMapOvr>
+    <a:masterClrMapping/>
+  </p:clrMapOvr>
+</p:sld>
+</file>
+
+<file path=ppt/slides/slide26.xml><?xml version="1.0" encoding="utf-8"?>
 <p:sld xmlns:a="http://schemas.openxmlformats.org/drawingml/2006/main" xmlns:p="http://schemas.openxmlformats.org/presentationml/2006/main" xmlns:r="http://schemas.openxmlformats.org/officeDocument/2006/relationships">
   <p:cSld>
     <p:spTree>
@@ -22664,7 +23743,7 @@
 </p:sld>
 </file>
 
-<file path=ppt/slides/slide24.xml><?xml version="1.0" encoding="utf-8"?>
+<file path=ppt/slides/slide27.xml><?xml version="1.0" encoding="utf-8"?>
 <p:sld xmlns:a="http://schemas.openxmlformats.org/drawingml/2006/main" xmlns:p="http://schemas.openxmlformats.org/presentationml/2006/main" xmlns:r="http://schemas.openxmlformats.org/officeDocument/2006/relationships">
   <p:cSld>
     <p:spTree>
@@ -22944,7 +24023,7 @@
 </p:sld>
 </file>
 
-<file path=ppt/slides/slide25.xml><?xml version="1.0" encoding="utf-8"?>
+<file path=ppt/slides/slide28.xml><?xml version="1.0" encoding="utf-8"?>
 <p:sld xmlns:a="http://schemas.openxmlformats.org/drawingml/2006/main" xmlns:p="http://schemas.openxmlformats.org/presentationml/2006/main" xmlns:r="http://schemas.openxmlformats.org/officeDocument/2006/relationships">
   <p:cSld>
     <p:spTree>
@@ -23160,7 +24239,7 @@
 </p:sld>
 </file>
 
-<file path=ppt/slides/slide26.xml><?xml version="1.0" encoding="utf-8"?>
+<file path=ppt/slides/slide29.xml><?xml version="1.0" encoding="utf-8"?>
 <p:sld xmlns:a="http://schemas.openxmlformats.org/drawingml/2006/main" xmlns:p="http://schemas.openxmlformats.org/presentationml/2006/main" xmlns:r="http://schemas.openxmlformats.org/officeDocument/2006/relationships">
   <p:cSld>
     <p:spTree>

</xml_diff>

<commit_message>
Agenda-Nummerierung korrigiert: Exkurs als Unterpunkt 6a statt eigener Hauptpunkt
Exkurs (200% vs 120%) wird jetzt als "6a." eingerückt dargestellt,
Hauptpunkte von 9 auf 8 reduziert. Markdown-TOC ebenfalls angepasst.

https://claude.ai/code/session_015mHD4NfjMbda5YrGvujwfD
</commit_message>
<xml_diff>
--- a/docs/VDI-Vergleichsanalyse.pptx
+++ b/docs/VDI-Vergleichsanalyse.pptx
@@ -20314,6 +20314,22 @@
             </a:r>
           </a:p>
           <a:p>
+            <a:pPr lvl="1">
+              <a:spcAft>
+                <a:spcPts val="1000"/>
+              </a:spcAft>
+            </a:pPr>
+            <a:r>
+              <a:rPr sz="1600" b="0">
+                <a:solidFill>
+                  <a:srgbClr val="333333"/>
+                </a:solidFill>
+                <a:latin typeface="AOK Bundesweit"/>
+              </a:rPr>
+              <a:t>6a.  Exkurs: 200 % vs. 120 % Kapazität</a:t>
+            </a:r>
+          </a:p>
+          <a:p>
             <a:pPr>
               <a:spcAft>
                 <a:spcPts val="1000"/>
@@ -20326,7 +20342,7 @@
                 </a:solidFill>
                 <a:latin typeface="AOK Bundesweit"/>
               </a:rPr>
-              <a:t>7.  Exkurs: 200 % vs. 120 % Kapazität</a:t>
+              <a:t>7.  Bewertungsmatrix und Empfehlung</a:t>
             </a:r>
           </a:p>
           <a:p>
@@ -20342,23 +20358,7 @@
                 </a:solidFill>
                 <a:latin typeface="AOK Bundesweit"/>
               </a:rPr>
-              <a:t>8.  Bewertungsmatrix und Empfehlung</a:t>
-            </a:r>
-          </a:p>
-          <a:p>
-            <a:pPr>
-              <a:spcAft>
-                <a:spcPts val="1000"/>
-              </a:spcAft>
-            </a:pPr>
-            <a:r>
-              <a:rPr sz="1800" b="0">
-                <a:solidFill>
-                  <a:srgbClr val="333333"/>
-                </a:solidFill>
-                <a:latin typeface="AOK Bundesweit"/>
-              </a:rPr>
-              <a:t>9.  Nächste Schritte</a:t>
+              <a:t>8.  Nächste Schritte</a:t>
             </a:r>
           </a:p>
         </p:txBody>

</xml_diff>